<commit_message>
fix: mul(M-extension) works, correct earlier claim in docs/deck; add diagnostics
</commit_message>
<xml_diff>
--- a/docs/Coral_NPU_ZCU102.pptx
+++ b/docs/Coral_NPU_ZCU102.pptx
@@ -7879,7 +7879,7 @@
                 <a:ea typeface="Cambria" pitchFamily="34" charset="-122"/>
                 <a:cs typeface="Cambria" pitchFamily="34" charset="-120"/>
               </a:rPr>
-              <a:t>HW 곱셈기 미동작</a:t>
+              <a:t>곱셈기 = LUT 구현</a:t>
             </a:r>
             <a:endParaRPr lang="en-US" sz="1800" dirty="0"/>
           </a:p>
@@ -7921,7 +7921,7 @@
                 <a:ea typeface="Calibri" pitchFamily="34" charset="-122"/>
                 <a:cs typeface="Calibri" pitchFamily="34" charset="-120"/>
               </a:rPr>
-              <a:t>mul 명령 시 코어 정지 → shift+add SW 우회. 16 MAC에 ~541 명령어 소요.</a:t>
+              <a:t>곱셈은 정상 동작(mul 실측 확인). 단 DSP 아닌 LUT로 구현되어 면적·속도 효율은 개선 여지.</a:t>
             </a:r>
             <a:endParaRPr lang="en-US" sz="1400" dirty="0"/>
           </a:p>

</xml_diff>

<commit_message>
MNIST on NPU: int8 quantization (98% no loss), perf measurement, docs and deck updated
</commit_message>
<xml_diff>
--- a/docs/Coral_NPU_ZCU102.pptx
+++ b/docs/Coral_NPU_ZCU102.pptx
@@ -15,9 +15,10 @@
     <p:sldId id="263" r:id="rId9"/>
     <p:sldId id="264" r:id="rId10"/>
     <p:sldId id="265" r:id="rId11"/>
+    <p:sldId id="266" r:id="rId12"/>
   </p:sldIdLst>
   <p:notesMasterIdLst>
-    <p:notesMasterId r:id="rId12"/>
+    <p:notesMasterId r:id="rId13"/>
   </p:notesMasterIdLst>
   <p:sldSz cx="12192000" cy="6858000"/>
   <p:notesSz cx="6858000" cy="12192000"/>
@@ -117,6 +118,230 @@
 </file>
 
 <file path=ppt/charts/chart1.xml><?xml version="1.0" encoding="utf-8"?>
+<c:chartSpace xmlns:c="http://schemas.openxmlformats.org/drawingml/2006/chart" xmlns:a="http://schemas.openxmlformats.org/drawingml/2006/main" xmlns:r="http://schemas.openxmlformats.org/officeDocument/2006/relationships">
+  <c:date1904 val="0"/>
+  <c:roundedCorners val="1"/>
+  <c:chart>
+    <c:autoTitleDeleted val="1"/>
+    <c:plotArea>
+      <c:layout/>
+      <c:barChart>
+        <c:barDir val="col"/>
+        <c:grouping val="clustered"/>
+        <c:varyColors val="0"/>
+        <c:ser>
+          <c:idx val="0"/>
+          <c:order val="0"/>
+          <c:tx>
+            <c:strRef>
+              <c:f>Sheet1!$B$1</c:f>
+              <c:strCache>
+                <c:ptCount val="1"/>
+                <c:pt idx="0">
+                  <c:v>bytes</c:v>
+                </c:pt>
+              </c:strCache>
+            </c:strRef>
+          </c:tx>
+          <c:spPr>
+            <a:solidFill>
+              <a:srgbClr val="2F3C7E"/>
+            </a:solidFill>
+            <a:effectLst/>
+          </c:spPr>
+          <c:invertIfNegative val="0"/>
+          <c:dLbls>
+            <c:numFmt formatCode="#,##0" sourceLinked="0"/>
+            <c:txPr>
+              <a:bodyPr/>
+              <a:lstStyle/>
+              <a:p>
+                <a:pPr>
+                  <a:defRPr b="0" i="0" strike="noStrike" sz="1100" u="none">
+                    <a:solidFill>
+                      <a:srgbClr val="1A1F3D"/>
+                    </a:solidFill>
+                    <a:latin typeface="Calibri"/>
+                  </a:defRPr>
+                </a:pPr>
+              </a:p>
+            </c:txPr>
+            <c:showLegendKey val="0"/>
+            <c:showVal val="1"/>
+            <c:showCatName val="0"/>
+            <c:showSerName val="0"/>
+            <c:showPercent val="0"/>
+            <c:showBubbleSize val="0"/>
+            <c:showLeaderLines val="0"/>
+          </c:dLbls>
+          <c:cat>
+            <c:multiLvlStrRef>
+              <c:f>Sheet1!$A$2:$A$3</c:f>
+              <c:multiLvlStrCache>
+                <c:ptCount val="2"/>
+                <c:lvl>
+                  <c:pt idx="0">
+                    <c:v>float32</c:v>
+                  </c:pt>
+                  <c:pt idx="1">
+                    <c:v>int8</c:v>
+                  </c:pt>
+                </c:lvl>
+              </c:multiLvlStrCache>
+            </c:multiLvlStrRef>
+          </c:cat>
+          <c:val>
+            <c:numRef>
+              <c:f>Sheet1!$B$2:$B$3</c:f>
+              <c:numCache>
+                <c:formatCode>General</c:formatCode>
+                <c:ptCount val="2"/>
+                <c:pt idx="0">
+                  <c:v>9640</c:v>
+                </c:pt>
+                <c:pt idx="1">
+                  <c:v>2368</c:v>
+                </c:pt>
+              </c:numCache>
+            </c:numRef>
+          </c:val>
+        </c:ser>
+        <c:dLbls>
+          <c:numFmt formatCode="#,##0" sourceLinked="0"/>
+          <c:txPr>
+            <a:bodyPr/>
+            <a:lstStyle/>
+            <a:p>
+              <a:pPr>
+                <a:defRPr b="0" i="0" strike="noStrike" sz="1100" u="none">
+                  <a:solidFill>
+                    <a:srgbClr val="1A1F3D"/>
+                  </a:solidFill>
+                  <a:latin typeface="Calibri"/>
+                </a:defRPr>
+              </a:pPr>
+            </a:p>
+          </c:txPr>
+          <c:showLegendKey val="0"/>
+          <c:showVal val="1"/>
+          <c:showCatName val="0"/>
+          <c:showSerName val="0"/>
+          <c:showPercent val="0"/>
+          <c:showBubbleSize val="0"/>
+          <c:showLeaderLines val="0"/>
+        </c:dLbls>
+        <c:gapWidth val="150"/>
+        <c:overlap val="0"/>
+        <c:axId val="2094734554"/>
+        <c:axId val="2094734552"/>
+        <c:axId val="2094734556"/>
+      </c:barChart>
+      <c:catAx>
+        <c:axId val="2094734554"/>
+        <c:scaling>
+          <c:orientation val="minMax"/>
+        </c:scaling>
+        <c:delete val="0"/>
+        <c:axPos val="b"/>
+        <c:numFmt formatCode="General" sourceLinked="1"/>
+        <c:majorTickMark val="out"/>
+        <c:minorTickMark val="none"/>
+        <c:tickLblPos val="low"/>
+        <c:spPr>
+          <a:ln w="12700" cap="flat">
+            <a:solidFill>
+              <a:srgbClr val="888888"/>
+            </a:solidFill>
+            <a:prstDash val="solid"/>
+            <a:round/>
+          </a:ln>
+        </c:spPr>
+        <c:txPr>
+          <a:bodyPr/>
+          <a:lstStyle/>
+          <a:p>
+            <a:pPr>
+              <a:defRPr sz="1300" b="0" i="0" u="none" strike="noStrike">
+                <a:solidFill>
+                  <a:srgbClr val="5A6072"/>
+                </a:solidFill>
+                <a:latin typeface="Calibri"/>
+              </a:defRPr>
+            </a:pPr>
+            <a:endParaRPr lang="en-US"/>
+          </a:p>
+        </c:txPr>
+        <c:crossAx val="2094734552"/>
+        <c:crosses val="autoZero"/>
+        <c:auto val="1"/>
+        <c:lblAlgn val="ctr"/>
+        <c:noMultiLvlLbl val="1"/>
+      </c:catAx>
+      <c:valAx>
+        <c:axId val="2094734552"/>
+        <c:scaling>
+          <c:orientation val="minMax"/>
+          <c:max val="11000"/>
+        </c:scaling>
+        <c:delete val="1"/>
+        <c:axPos val="l"/>
+        <c:numFmt formatCode="General" sourceLinked="0"/>
+        <c:majorTickMark val="out"/>
+        <c:minorTickMark val="none"/>
+        <c:tickLblPos val="nextTo"/>
+        <c:spPr>
+          <a:ln w="12700" cap="flat">
+            <a:solidFill>
+              <a:srgbClr val="888888"/>
+            </a:solidFill>
+            <a:prstDash val="solid"/>
+            <a:round/>
+          </a:ln>
+        </c:spPr>
+        <c:txPr>
+          <a:bodyPr/>
+          <a:lstStyle/>
+          <a:p>
+            <a:pPr>
+              <a:defRPr sz="1200" b="0" i="0" u="none" strike="noStrike">
+                <a:solidFill>
+                  <a:srgbClr val="000000"/>
+                </a:solidFill>
+                <a:latin typeface="Arial"/>
+              </a:defRPr>
+            </a:pPr>
+            <a:endParaRPr lang="en-US"/>
+          </a:p>
+        </c:txPr>
+        <c:crossAx val="2094734554"/>
+        <c:crosses val="autoZero"/>
+        <c:crossBetween val="between"/>
+      </c:valAx>
+      <c:spPr>
+        <a:noFill/>
+        <a:ln>
+          <a:noFill/>
+        </a:ln>
+        <a:effectLst/>
+      </c:spPr>
+    </c:plotArea>
+    <c:plotVisOnly val="1"/>
+    <c:dispBlanksAs val="span"/>
+  </c:chart>
+  <c:spPr>
+    <a:noFill/>
+    <a:ln>
+      <a:noFill/>
+    </a:ln>
+    <a:effectLst/>
+  </c:spPr>
+  <c:externalData r:id="rId1">
+    <c:autoUpdate val="0"/>
+  </c:externalData>
+</c:chartSpace>
+</file>
+
+<file path=ppt/charts/chart2.xml><?xml version="1.0" encoding="utf-8"?>
 <c:chartSpace xmlns:c="http://schemas.openxmlformats.org/drawingml/2006/chart" xmlns:a="http://schemas.openxmlformats.org/drawingml/2006/main" xmlns:r="http://schemas.openxmlformats.org/officeDocument/2006/relationships">
   <c:date1904 val="0"/>
   <c:roundedCorners val="1"/>
@@ -860,6 +1085,94 @@
             <a:fld id="{F7021451-1387-4CA6-816F-3879F97B5CBC}" type="slidenum">
               <a:rPr lang="en-US"/>
               <a:t>10</a:t>
+            </a:fld>
+            <a:endParaRPr lang="en-US"/>
+          </a:p>
+        </p:txBody>
+      </p:sp>
+    </p:spTree>
+    <p:extLst>
+      <p:ext uri="{BB962C8B-B14F-4D97-AF65-F5344CB8AC3E}">
+        <p14:creationId xmlns:p14="http://schemas.microsoft.com/office/powerpoint/2010/main" val="1024086991"/>
+      </p:ext>
+    </p:extLst>
+  </p:cSld>
+  <p:clrMapOvr>
+    <a:masterClrMapping/>
+  </p:clrMapOvr>
+</p:notes>
+</file>
+
+<file path=ppt/notesSlides/notesSlide11.xml><?xml version="1.0" encoding="utf-8"?>
+<p:notes xmlns:a="http://schemas.openxmlformats.org/drawingml/2006/main" xmlns:r="http://schemas.openxmlformats.org/officeDocument/2006/relationships" xmlns:p="http://schemas.openxmlformats.org/presentationml/2006/main">
+  <p:cSld>
+    <p:spTree>
+      <p:nvGrpSpPr>
+        <p:cNvPr id="1" name=""/>
+        <p:cNvGrpSpPr/>
+        <p:nvPr/>
+      </p:nvGrpSpPr>
+      <p:grpSpPr>
+        <a:xfrm>
+          <a:off x="0" y="0"/>
+          <a:ext cx="0" cy="0"/>
+          <a:chOff x="0" y="0"/>
+          <a:chExt cx="0" cy="0"/>
+        </a:xfrm>
+      </p:grpSpPr>
+      <p:sp>
+        <p:nvSpPr>
+          <p:cNvPr id="2" name="Slide Image Placeholder 1"/>
+          <p:cNvSpPr>
+            <a:spLocks noGrp="1" noRot="1" noChangeAspect="1"/>
+          </p:cNvSpPr>
+          <p:nvPr>
+            <p:ph type="sldImg"/>
+          </p:nvPr>
+        </p:nvSpPr>
+        <p:spPr/>
+      </p:sp>
+      <p:sp>
+        <p:nvSpPr>
+          <p:cNvPr id="3" name="Notes Placeholder 2"/>
+          <p:cNvSpPr>
+            <a:spLocks noGrp="1"/>
+          </p:cNvSpPr>
+          <p:nvPr>
+            <p:ph type="body" idx="1"/>
+          </p:nvPr>
+        </p:nvSpPr>
+        <p:spPr/>
+        <p:txBody>
+          <a:bodyPr/>
+          <a:lstStyle/>
+          <a:p>
+            <a:r>
+              <a:rPr lang="en-US" dirty="0"/>
+              <a:t/>
+            </a:r>
+            <a:endParaRPr lang="en-US" dirty="0"/>
+          </a:p>
+        </p:txBody>
+      </p:sp>
+      <p:sp>
+        <p:nvSpPr>
+          <p:cNvPr id="4" name="Slide Number Placeholder 3"/>
+          <p:cNvSpPr>
+            <a:spLocks noGrp="1"/>
+          </p:cNvSpPr>
+          <p:nvPr>
+            <p:ph type="sldNum" sz="quarter" idx="10"/>
+          </p:nvPr>
+        </p:nvSpPr>
+        <p:spPr/>
+        <p:txBody>
+          <a:bodyPr/>
+          <a:lstStyle/>
+          <a:p>
+            <a:fld id="{F7021451-1387-4CA6-816F-3879F97B5CBC}" type="slidenum">
+              <a:rPr lang="en-US"/>
+              <a:t>11</a:t>
             </a:fld>
             <a:endParaRPr lang="en-US"/>
           </a:p>
@@ -2126,6 +2439,812 @@
     <p:bg>
       <p:bgPr>
         <a:solidFill>
+          <a:srgbClr val="F5F7FB"/>
+        </a:solidFill>
+      </p:bgPr>
+    </p:bg>
+    <p:spTree>
+      <p:nvGrpSpPr>
+        <p:cNvPr id="1" name=""/>
+        <p:cNvGrpSpPr/>
+        <p:nvPr/>
+      </p:nvGrpSpPr>
+      <p:grpSpPr>
+        <a:xfrm>
+          <a:off x="0" y="0"/>
+          <a:ext cx="0" cy="0"/>
+          <a:chOff x="0" y="0"/>
+          <a:chExt cx="0" cy="0"/>
+        </a:xfrm>
+      </p:grpSpPr>
+      <p:sp>
+        <p:nvSpPr>
+          <p:cNvPr id="2" name="Text 0"/>
+          <p:cNvSpPr/>
+          <p:nvPr/>
+        </p:nvSpPr>
+        <p:spPr>
+          <a:xfrm>
+            <a:off x="640080" y="502920"/>
+            <a:ext cx="5486400" cy="274320"/>
+          </a:xfrm>
+          <a:prstGeom prst="rect">
+            <a:avLst/>
+          </a:prstGeom>
+          <a:noFill/>
+          <a:ln/>
+        </p:spPr>
+        <p:txBody>
+          <a:bodyPr wrap="square" lIns="0" tIns="0" rIns="0" bIns="0" rtlCol="0" anchor="ctr"/>
+          <a:lstStyle/>
+          <a:p>
+            <a:pPr indent="0" marL="0">
+              <a:buNone/>
+            </a:pPr>
+            <a:r>
+              <a:rPr lang="en-US" sz="1200" b="1" spc="200" kern="0" dirty="0">
+                <a:solidFill>
+                  <a:srgbClr val="F96167"/>
+                </a:solidFill>
+                <a:latin typeface="Calibri" pitchFamily="34" charset="0"/>
+                <a:ea typeface="Calibri" pitchFamily="34" charset="-122"/>
+                <a:cs typeface="Calibri" pitchFamily="34" charset="-120"/>
+              </a:rPr>
+              <a:t>LIMITATIONS</a:t>
+            </a:r>
+            <a:endParaRPr lang="en-US" sz="1200" dirty="0"/>
+          </a:p>
+        </p:txBody>
+      </p:sp>
+      <p:sp>
+        <p:nvSpPr>
+          <p:cNvPr id="3" name="Text 1"/>
+          <p:cNvSpPr/>
+          <p:nvPr/>
+        </p:nvSpPr>
+        <p:spPr>
+          <a:xfrm>
+            <a:off x="594360" y="777240"/>
+            <a:ext cx="10058400" cy="731520"/>
+          </a:xfrm>
+          <a:prstGeom prst="rect">
+            <a:avLst/>
+          </a:prstGeom>
+          <a:noFill/>
+          <a:ln/>
+        </p:spPr>
+        <p:txBody>
+          <a:bodyPr wrap="square" lIns="0" tIns="0" rIns="0" bIns="0" rtlCol="0" anchor="ctr"/>
+          <a:lstStyle/>
+          <a:p>
+            <a:pPr indent="0" marL="0">
+              <a:buNone/>
+            </a:pPr>
+            <a:r>
+              <a:rPr lang="en-US" sz="3400" b="1" dirty="0">
+                <a:solidFill>
+                  <a:srgbClr val="1A1F3D"/>
+                </a:solidFill>
+                <a:latin typeface="Cambria" pitchFamily="34" charset="0"/>
+                <a:ea typeface="Cambria" pitchFamily="34" charset="-122"/>
+                <a:cs typeface="Cambria" pitchFamily="34" charset="-120"/>
+              </a:rPr>
+              <a:t>한계 분석</a:t>
+            </a:r>
+            <a:endParaRPr lang="en-US" sz="3400" dirty="0"/>
+          </a:p>
+        </p:txBody>
+      </p:sp>
+      <p:sp>
+        <p:nvSpPr>
+          <p:cNvPr id="4" name="Shape 2"/>
+          <p:cNvSpPr/>
+          <p:nvPr/>
+        </p:nvSpPr>
+        <p:spPr>
+          <a:xfrm>
+            <a:off x="640080" y="1783080"/>
+            <a:ext cx="5349240" cy="1874520"/>
+          </a:xfrm>
+          <a:prstGeom prst="roundRect">
+            <a:avLst>
+              <a:gd name="adj" fmla="val 4878"/>
+            </a:avLst>
+          </a:prstGeom>
+          <a:solidFill>
+            <a:srgbClr val="FFFFFF"/>
+          </a:solidFill>
+          <a:ln w="12700">
+            <a:solidFill>
+              <a:srgbClr val="E2E6F0"/>
+            </a:solidFill>
+            <a:prstDash val="solid"/>
+          </a:ln>
+          <a:effectLst>
+            <a:outerShdw sx="100000" sy="100000" kx="0" ky="0" algn="bl" rotWithShape="0" blurRad="101600" dist="25400" dir="5400000">
+              <a:srgbClr val="9099B0">
+                <a:alpha val="30000"/>
+              </a:srgbClr>
+            </a:outerShdw>
+          </a:effectLst>
+        </p:spPr>
+      </p:sp>
+      <p:sp>
+        <p:nvSpPr>
+          <p:cNvPr id="5" name="Shape 3"/>
+          <p:cNvSpPr/>
+          <p:nvPr/>
+        </p:nvSpPr>
+        <p:spPr>
+          <a:xfrm>
+            <a:off x="960120" y="2084832"/>
+            <a:ext cx="310896" cy="310896"/>
+          </a:xfrm>
+          <a:prstGeom prst="ellipse">
+            <a:avLst/>
+          </a:prstGeom>
+          <a:solidFill>
+            <a:srgbClr val="F96167"/>
+          </a:solidFill>
+          <a:ln/>
+        </p:spPr>
+      </p:sp>
+      <p:sp>
+        <p:nvSpPr>
+          <p:cNvPr id="6" name="Text 4"/>
+          <p:cNvSpPr/>
+          <p:nvPr/>
+        </p:nvSpPr>
+        <p:spPr>
+          <a:xfrm>
+            <a:off x="960120" y="2066544"/>
+            <a:ext cx="310896" cy="310896"/>
+          </a:xfrm>
+          <a:prstGeom prst="rect">
+            <a:avLst/>
+          </a:prstGeom>
+          <a:noFill/>
+          <a:ln/>
+        </p:spPr>
+        <p:txBody>
+          <a:bodyPr wrap="square" lIns="0" tIns="0" rIns="0" bIns="0" rtlCol="0" anchor="ctr"/>
+          <a:lstStyle/>
+          <a:p>
+            <a:pPr algn="ctr" indent="0" marL="0">
+              <a:buNone/>
+            </a:pPr>
+            <a:r>
+              <a:rPr lang="en-US" sz="1500" b="1" dirty="0">
+                <a:solidFill>
+                  <a:srgbClr val="FFFFFF"/>
+                </a:solidFill>
+                <a:latin typeface="Cambria" pitchFamily="34" charset="0"/>
+                <a:ea typeface="Cambria" pitchFamily="34" charset="-122"/>
+                <a:cs typeface="Cambria" pitchFamily="34" charset="-120"/>
+              </a:rPr>
+              <a:t>1</a:t>
+            </a:r>
+            <a:endParaRPr lang="en-US" sz="1500" dirty="0"/>
+          </a:p>
+        </p:txBody>
+      </p:sp>
+      <p:sp>
+        <p:nvSpPr>
+          <p:cNvPr id="7" name="Text 5"/>
+          <p:cNvSpPr/>
+          <p:nvPr/>
+        </p:nvSpPr>
+        <p:spPr>
+          <a:xfrm>
+            <a:off x="1417320" y="2039112"/>
+            <a:ext cx="4297680" cy="411480"/>
+          </a:xfrm>
+          <a:prstGeom prst="rect">
+            <a:avLst/>
+          </a:prstGeom>
+          <a:noFill/>
+          <a:ln/>
+        </p:spPr>
+        <p:txBody>
+          <a:bodyPr wrap="square" lIns="0" tIns="0" rIns="0" bIns="0" rtlCol="0" anchor="ctr"/>
+          <a:lstStyle/>
+          <a:p>
+            <a:pPr indent="0" marL="0">
+              <a:buNone/>
+            </a:pPr>
+            <a:r>
+              <a:rPr lang="en-US" sz="1800" b="1" dirty="0">
+                <a:solidFill>
+                  <a:srgbClr val="1A1F3D"/>
+                </a:solidFill>
+                <a:latin typeface="Cambria" pitchFamily="34" charset="0"/>
+                <a:ea typeface="Cambria" pitchFamily="34" charset="-122"/>
+                <a:cs typeface="Cambria" pitchFamily="34" charset="-120"/>
+              </a:rPr>
+              <a:t>곱셈기 = LUT 구현</a:t>
+            </a:r>
+            <a:endParaRPr lang="en-US" sz="1800" dirty="0"/>
+          </a:p>
+        </p:txBody>
+      </p:sp>
+      <p:sp>
+        <p:nvSpPr>
+          <p:cNvPr id="8" name="Text 6"/>
+          <p:cNvSpPr/>
+          <p:nvPr/>
+        </p:nvSpPr>
+        <p:spPr>
+          <a:xfrm>
+            <a:off x="1005840" y="2606040"/>
+            <a:ext cx="4709160" cy="960120"/>
+          </a:xfrm>
+          <a:prstGeom prst="rect">
+            <a:avLst/>
+          </a:prstGeom>
+          <a:noFill/>
+          <a:ln/>
+        </p:spPr>
+        <p:txBody>
+          <a:bodyPr wrap="square" lIns="0" tIns="0" rIns="0" bIns="0" rtlCol="0" anchor="ctr"/>
+          <a:lstStyle/>
+          <a:p>
+            <a:pPr indent="0" marL="0">
+              <a:lnSpc>
+                <a:spcPct val="105000"/>
+              </a:lnSpc>
+              <a:buNone/>
+            </a:pPr>
+            <a:r>
+              <a:rPr lang="en-US" sz="1400" dirty="0">
+                <a:solidFill>
+                  <a:srgbClr val="5A6072"/>
+                </a:solidFill>
+                <a:latin typeface="Calibri" pitchFamily="34" charset="0"/>
+                <a:ea typeface="Calibri" pitchFamily="34" charset="-122"/>
+                <a:cs typeface="Calibri" pitchFamily="34" charset="-120"/>
+              </a:rPr>
+              <a:t>곱셈은 정상 동작(mul 실측 확인). 단 DSP 아닌 LUT로 구현되어 면적·속도 효율은 개선 여지.</a:t>
+            </a:r>
+            <a:endParaRPr lang="en-US" sz="1400" dirty="0"/>
+          </a:p>
+        </p:txBody>
+      </p:sp>
+      <p:sp>
+        <p:nvSpPr>
+          <p:cNvPr id="9" name="Shape 7"/>
+          <p:cNvSpPr/>
+          <p:nvPr/>
+        </p:nvSpPr>
+        <p:spPr>
+          <a:xfrm>
+            <a:off x="6263640" y="1783080"/>
+            <a:ext cx="5349240" cy="1874520"/>
+          </a:xfrm>
+          <a:prstGeom prst="roundRect">
+            <a:avLst>
+              <a:gd name="adj" fmla="val 4878"/>
+            </a:avLst>
+          </a:prstGeom>
+          <a:solidFill>
+            <a:srgbClr val="FFFFFF"/>
+          </a:solidFill>
+          <a:ln w="12700">
+            <a:solidFill>
+              <a:srgbClr val="E2E6F0"/>
+            </a:solidFill>
+            <a:prstDash val="solid"/>
+          </a:ln>
+          <a:effectLst>
+            <a:outerShdw sx="100000" sy="100000" kx="0" ky="0" algn="bl" rotWithShape="0" blurRad="101600" dist="25400" dir="5400000">
+              <a:srgbClr val="9099B0">
+                <a:alpha val="30000"/>
+              </a:srgbClr>
+            </a:outerShdw>
+          </a:effectLst>
+        </p:spPr>
+      </p:sp>
+      <p:sp>
+        <p:nvSpPr>
+          <p:cNvPr id="10" name="Shape 8"/>
+          <p:cNvSpPr/>
+          <p:nvPr/>
+        </p:nvSpPr>
+        <p:spPr>
+          <a:xfrm>
+            <a:off x="6583680" y="2084832"/>
+            <a:ext cx="310896" cy="310896"/>
+          </a:xfrm>
+          <a:prstGeom prst="ellipse">
+            <a:avLst/>
+          </a:prstGeom>
+          <a:solidFill>
+            <a:srgbClr val="F96167"/>
+          </a:solidFill>
+          <a:ln/>
+        </p:spPr>
+      </p:sp>
+      <p:sp>
+        <p:nvSpPr>
+          <p:cNvPr id="11" name="Text 9"/>
+          <p:cNvSpPr/>
+          <p:nvPr/>
+        </p:nvSpPr>
+        <p:spPr>
+          <a:xfrm>
+            <a:off x="6583680" y="2066544"/>
+            <a:ext cx="310896" cy="310896"/>
+          </a:xfrm>
+          <a:prstGeom prst="rect">
+            <a:avLst/>
+          </a:prstGeom>
+          <a:noFill/>
+          <a:ln/>
+        </p:spPr>
+        <p:txBody>
+          <a:bodyPr wrap="square" lIns="0" tIns="0" rIns="0" bIns="0" rtlCol="0" anchor="ctr"/>
+          <a:lstStyle/>
+          <a:p>
+            <a:pPr algn="ctr" indent="0" marL="0">
+              <a:buNone/>
+            </a:pPr>
+            <a:r>
+              <a:rPr lang="en-US" sz="1500" b="1" dirty="0">
+                <a:solidFill>
+                  <a:srgbClr val="FFFFFF"/>
+                </a:solidFill>
+                <a:latin typeface="Cambria" pitchFamily="34" charset="0"/>
+                <a:ea typeface="Cambria" pitchFamily="34" charset="-122"/>
+                <a:cs typeface="Cambria" pitchFamily="34" charset="-120"/>
+              </a:rPr>
+              <a:t>2</a:t>
+            </a:r>
+            <a:endParaRPr lang="en-US" sz="1500" dirty="0"/>
+          </a:p>
+        </p:txBody>
+      </p:sp>
+      <p:sp>
+        <p:nvSpPr>
+          <p:cNvPr id="12" name="Text 10"/>
+          <p:cNvSpPr/>
+          <p:nvPr/>
+        </p:nvSpPr>
+        <p:spPr>
+          <a:xfrm>
+            <a:off x="7040880" y="2039112"/>
+            <a:ext cx="4297680" cy="411480"/>
+          </a:xfrm>
+          <a:prstGeom prst="rect">
+            <a:avLst/>
+          </a:prstGeom>
+          <a:noFill/>
+          <a:ln/>
+        </p:spPr>
+        <p:txBody>
+          <a:bodyPr wrap="square" lIns="0" tIns="0" rIns="0" bIns="0" rtlCol="0" anchor="ctr"/>
+          <a:lstStyle/>
+          <a:p>
+            <a:pPr indent="0" marL="0">
+              <a:buNone/>
+            </a:pPr>
+            <a:r>
+              <a:rPr lang="en-US" sz="1800" b="1" dirty="0">
+                <a:solidFill>
+                  <a:srgbClr val="1A1F3D"/>
+                </a:solidFill>
+                <a:latin typeface="Cambria" pitchFamily="34" charset="0"/>
+                <a:ea typeface="Cambria" pitchFamily="34" charset="-122"/>
+                <a:cs typeface="Cambria" pitchFamily="34" charset="-120"/>
+              </a:rPr>
+              <a:t>칩 규모 (최대 이슈)</a:t>
+            </a:r>
+            <a:endParaRPr lang="en-US" sz="1800" dirty="0"/>
+          </a:p>
+        </p:txBody>
+      </p:sp>
+      <p:sp>
+        <p:nvSpPr>
+          <p:cNvPr id="13" name="Text 11"/>
+          <p:cNvSpPr/>
+          <p:nvPr/>
+        </p:nvSpPr>
+        <p:spPr>
+          <a:xfrm>
+            <a:off x="6629400" y="2606040"/>
+            <a:ext cx="4709160" cy="960120"/>
+          </a:xfrm>
+          <a:prstGeom prst="rect">
+            <a:avLst/>
+          </a:prstGeom>
+          <a:noFill/>
+          <a:ln/>
+        </p:spPr>
+        <p:txBody>
+          <a:bodyPr wrap="square" lIns="0" tIns="0" rIns="0" bIns="0" rtlCol="0" anchor="ctr"/>
+          <a:lstStyle/>
+          <a:p>
+            <a:pPr indent="0" marL="0">
+              <a:lnSpc>
+                <a:spcPct val="105000"/>
+              </a:lnSpc>
+              <a:buNone/>
+            </a:pPr>
+            <a:r>
+              <a:rPr lang="en-US" sz="1400" dirty="0">
+                <a:solidFill>
+                  <a:srgbClr val="5A6072"/>
+                </a:solidFill>
+                <a:latin typeface="Calibri" pitchFamily="34" charset="0"/>
+                <a:ea typeface="Calibri" pitchFamily="34" charset="-122"/>
+                <a:cs typeface="Calibri" pitchFamily="34" charset="-120"/>
+              </a:rPr>
+              <a:t>Coral 기본 타깃 xcvu13p 대비 ZU9EG는 약 6배 작음 → NPU 코어만 분리 합성.</a:t>
+            </a:r>
+            <a:endParaRPr lang="en-US" sz="1400" dirty="0"/>
+          </a:p>
+        </p:txBody>
+      </p:sp>
+      <p:sp>
+        <p:nvSpPr>
+          <p:cNvPr id="14" name="Shape 12"/>
+          <p:cNvSpPr/>
+          <p:nvPr/>
+        </p:nvSpPr>
+        <p:spPr>
+          <a:xfrm>
+            <a:off x="640080" y="3931920"/>
+            <a:ext cx="5349240" cy="1874520"/>
+          </a:xfrm>
+          <a:prstGeom prst="roundRect">
+            <a:avLst>
+              <a:gd name="adj" fmla="val 4878"/>
+            </a:avLst>
+          </a:prstGeom>
+          <a:solidFill>
+            <a:srgbClr val="FFFFFF"/>
+          </a:solidFill>
+          <a:ln w="12700">
+            <a:solidFill>
+              <a:srgbClr val="E2E6F0"/>
+            </a:solidFill>
+            <a:prstDash val="solid"/>
+          </a:ln>
+          <a:effectLst>
+            <a:outerShdw sx="100000" sy="100000" kx="0" ky="0" algn="bl" rotWithShape="0" blurRad="101600" dist="25400" dir="5400000">
+              <a:srgbClr val="9099B0">
+                <a:alpha val="30000"/>
+              </a:srgbClr>
+            </a:outerShdw>
+          </a:effectLst>
+        </p:spPr>
+      </p:sp>
+      <p:sp>
+        <p:nvSpPr>
+          <p:cNvPr id="15" name="Shape 13"/>
+          <p:cNvSpPr/>
+          <p:nvPr/>
+        </p:nvSpPr>
+        <p:spPr>
+          <a:xfrm>
+            <a:off x="960120" y="4233672"/>
+            <a:ext cx="310896" cy="310896"/>
+          </a:xfrm>
+          <a:prstGeom prst="ellipse">
+            <a:avLst/>
+          </a:prstGeom>
+          <a:solidFill>
+            <a:srgbClr val="F96167"/>
+          </a:solidFill>
+          <a:ln/>
+        </p:spPr>
+      </p:sp>
+      <p:sp>
+        <p:nvSpPr>
+          <p:cNvPr id="16" name="Text 14"/>
+          <p:cNvSpPr/>
+          <p:nvPr/>
+        </p:nvSpPr>
+        <p:spPr>
+          <a:xfrm>
+            <a:off x="960120" y="4215384"/>
+            <a:ext cx="310896" cy="310896"/>
+          </a:xfrm>
+          <a:prstGeom prst="rect">
+            <a:avLst/>
+          </a:prstGeom>
+          <a:noFill/>
+          <a:ln/>
+        </p:spPr>
+        <p:txBody>
+          <a:bodyPr wrap="square" lIns="0" tIns="0" rIns="0" bIns="0" rtlCol="0" anchor="ctr"/>
+          <a:lstStyle/>
+          <a:p>
+            <a:pPr algn="ctr" indent="0" marL="0">
+              <a:buNone/>
+            </a:pPr>
+            <a:r>
+              <a:rPr lang="en-US" sz="1500" b="1" dirty="0">
+                <a:solidFill>
+                  <a:srgbClr val="FFFFFF"/>
+                </a:solidFill>
+                <a:latin typeface="Cambria" pitchFamily="34" charset="0"/>
+                <a:ea typeface="Cambria" pitchFamily="34" charset="-122"/>
+                <a:cs typeface="Cambria" pitchFamily="34" charset="-120"/>
+              </a:rPr>
+              <a:t>3</a:t>
+            </a:r>
+            <a:endParaRPr lang="en-US" sz="1500" dirty="0"/>
+          </a:p>
+        </p:txBody>
+      </p:sp>
+      <p:sp>
+        <p:nvSpPr>
+          <p:cNvPr id="17" name="Text 15"/>
+          <p:cNvSpPr/>
+          <p:nvPr/>
+        </p:nvSpPr>
+        <p:spPr>
+          <a:xfrm>
+            <a:off x="1417320" y="4187952"/>
+            <a:ext cx="4297680" cy="411480"/>
+          </a:xfrm>
+          <a:prstGeom prst="rect">
+            <a:avLst/>
+          </a:prstGeom>
+          <a:noFill/>
+          <a:ln/>
+        </p:spPr>
+        <p:txBody>
+          <a:bodyPr wrap="square" lIns="0" tIns="0" rIns="0" bIns="0" rtlCol="0" anchor="ctr"/>
+          <a:lstStyle/>
+          <a:p>
+            <a:pPr indent="0" marL="0">
+              <a:buNone/>
+            </a:pPr>
+            <a:r>
+              <a:rPr lang="en-US" sz="1800" b="1" dirty="0">
+                <a:solidFill>
+                  <a:srgbClr val="1A1F3D"/>
+                </a:solidFill>
+                <a:latin typeface="Cambria" pitchFamily="34" charset="0"/>
+                <a:ea typeface="Cambria" pitchFamily="34" charset="-122"/>
+                <a:cs typeface="Cambria" pitchFamily="34" charset="-120"/>
+              </a:rPr>
+              <a:t>클럭 상한 50MHz</a:t>
+            </a:r>
+            <a:endParaRPr lang="en-US" sz="1800" dirty="0"/>
+          </a:p>
+        </p:txBody>
+      </p:sp>
+      <p:sp>
+        <p:nvSpPr>
+          <p:cNvPr id="18" name="Text 16"/>
+          <p:cNvSpPr/>
+          <p:nvPr/>
+        </p:nvSpPr>
+        <p:spPr>
+          <a:xfrm>
+            <a:off x="1005840" y="4754880"/>
+            <a:ext cx="4709160" cy="960120"/>
+          </a:xfrm>
+          <a:prstGeom prst="rect">
+            <a:avLst/>
+          </a:prstGeom>
+          <a:noFill/>
+          <a:ln/>
+        </p:spPr>
+        <p:txBody>
+          <a:bodyPr wrap="square" lIns="0" tIns="0" rIns="0" bIns="0" rtlCol="0" anchor="ctr"/>
+          <a:lstStyle/>
+          <a:p>
+            <a:pPr indent="0" marL="0">
+              <a:lnSpc>
+                <a:spcPct val="105000"/>
+              </a:lnSpc>
+              <a:buNone/>
+            </a:pPr>
+            <a:r>
+              <a:rPr lang="en-US" sz="1400" dirty="0">
+                <a:solidFill>
+                  <a:srgbClr val="5A6072"/>
+                </a:solidFill>
+                <a:latin typeface="Calibri" pitchFamily="34" charset="0"/>
+                <a:ea typeface="Calibri" pitchFamily="34" charset="-122"/>
+                <a:cs typeface="Calibri" pitchFamily="34" charset="-120"/>
+              </a:rPr>
+              <a:t>100MHz는 타이밍 위반 → 50MHz로 하향해 안정 동작.</a:t>
+            </a:r>
+            <a:endParaRPr lang="en-US" sz="1400" dirty="0"/>
+          </a:p>
+        </p:txBody>
+      </p:sp>
+      <p:sp>
+        <p:nvSpPr>
+          <p:cNvPr id="19" name="Shape 17"/>
+          <p:cNvSpPr/>
+          <p:nvPr/>
+        </p:nvSpPr>
+        <p:spPr>
+          <a:xfrm>
+            <a:off x="6263640" y="3931920"/>
+            <a:ext cx="5349240" cy="1874520"/>
+          </a:xfrm>
+          <a:prstGeom prst="roundRect">
+            <a:avLst>
+              <a:gd name="adj" fmla="val 4878"/>
+            </a:avLst>
+          </a:prstGeom>
+          <a:solidFill>
+            <a:srgbClr val="FFFFFF"/>
+          </a:solidFill>
+          <a:ln w="12700">
+            <a:solidFill>
+              <a:srgbClr val="E2E6F0"/>
+            </a:solidFill>
+            <a:prstDash val="solid"/>
+          </a:ln>
+          <a:effectLst>
+            <a:outerShdw sx="100000" sy="100000" kx="0" ky="0" algn="bl" rotWithShape="0" blurRad="101600" dist="25400" dir="5400000">
+              <a:srgbClr val="9099B0">
+                <a:alpha val="30000"/>
+              </a:srgbClr>
+            </a:outerShdw>
+          </a:effectLst>
+        </p:spPr>
+      </p:sp>
+      <p:sp>
+        <p:nvSpPr>
+          <p:cNvPr id="20" name="Shape 18"/>
+          <p:cNvSpPr/>
+          <p:nvPr/>
+        </p:nvSpPr>
+        <p:spPr>
+          <a:xfrm>
+            <a:off x="6583680" y="4233672"/>
+            <a:ext cx="310896" cy="310896"/>
+          </a:xfrm>
+          <a:prstGeom prst="ellipse">
+            <a:avLst/>
+          </a:prstGeom>
+          <a:solidFill>
+            <a:srgbClr val="F96167"/>
+          </a:solidFill>
+          <a:ln/>
+        </p:spPr>
+      </p:sp>
+      <p:sp>
+        <p:nvSpPr>
+          <p:cNvPr id="21" name="Text 19"/>
+          <p:cNvSpPr/>
+          <p:nvPr/>
+        </p:nvSpPr>
+        <p:spPr>
+          <a:xfrm>
+            <a:off x="6583680" y="4215384"/>
+            <a:ext cx="310896" cy="310896"/>
+          </a:xfrm>
+          <a:prstGeom prst="rect">
+            <a:avLst/>
+          </a:prstGeom>
+          <a:noFill/>
+          <a:ln/>
+        </p:spPr>
+        <p:txBody>
+          <a:bodyPr wrap="square" lIns="0" tIns="0" rIns="0" bIns="0" rtlCol="0" anchor="ctr"/>
+          <a:lstStyle/>
+          <a:p>
+            <a:pPr algn="ctr" indent="0" marL="0">
+              <a:buNone/>
+            </a:pPr>
+            <a:r>
+              <a:rPr lang="en-US" sz="1500" b="1" dirty="0">
+                <a:solidFill>
+                  <a:srgbClr val="FFFFFF"/>
+                </a:solidFill>
+                <a:latin typeface="Cambria" pitchFamily="34" charset="0"/>
+                <a:ea typeface="Cambria" pitchFamily="34" charset="-122"/>
+                <a:cs typeface="Cambria" pitchFamily="34" charset="-120"/>
+              </a:rPr>
+              <a:t>4</a:t>
+            </a:r>
+            <a:endParaRPr lang="en-US" sz="1500" dirty="0"/>
+          </a:p>
+        </p:txBody>
+      </p:sp>
+      <p:sp>
+        <p:nvSpPr>
+          <p:cNvPr id="22" name="Text 20"/>
+          <p:cNvSpPr/>
+          <p:nvPr/>
+        </p:nvSpPr>
+        <p:spPr>
+          <a:xfrm>
+            <a:off x="7040880" y="4187952"/>
+            <a:ext cx="4297680" cy="411480"/>
+          </a:xfrm>
+          <a:prstGeom prst="rect">
+            <a:avLst/>
+          </a:prstGeom>
+          <a:noFill/>
+          <a:ln/>
+        </p:spPr>
+        <p:txBody>
+          <a:bodyPr wrap="square" lIns="0" tIns="0" rIns="0" bIns="0" rtlCol="0" anchor="ctr"/>
+          <a:lstStyle/>
+          <a:p>
+            <a:pPr indent="0" marL="0">
+              <a:buNone/>
+            </a:pPr>
+            <a:r>
+              <a:rPr lang="en-US" sz="1800" b="1" dirty="0">
+                <a:solidFill>
+                  <a:srgbClr val="1A1F3D"/>
+                </a:solidFill>
+                <a:latin typeface="Cambria" pitchFamily="34" charset="0"/>
+                <a:ea typeface="Cambria" pitchFamily="34" charset="-122"/>
+                <a:cs typeface="Cambria" pitchFamily="34" charset="-120"/>
+              </a:rPr>
+              <a:t>ZCU102 공식 미지원</a:t>
+            </a:r>
+            <a:endParaRPr lang="en-US" sz="1800" dirty="0"/>
+          </a:p>
+        </p:txBody>
+      </p:sp>
+      <p:sp>
+        <p:nvSpPr>
+          <p:cNvPr id="23" name="Text 21"/>
+          <p:cNvSpPr/>
+          <p:nvPr/>
+        </p:nvSpPr>
+        <p:spPr>
+          <a:xfrm>
+            <a:off x="6629400" y="4754880"/>
+            <a:ext cx="4709160" cy="960120"/>
+          </a:xfrm>
+          <a:prstGeom prst="rect">
+            <a:avLst/>
+          </a:prstGeom>
+          <a:noFill/>
+          <a:ln/>
+        </p:spPr>
+        <p:txBody>
+          <a:bodyPr wrap="square" lIns="0" tIns="0" rIns="0" bIns="0" rtlCol="0" anchor="ctr"/>
+          <a:lstStyle/>
+          <a:p>
+            <a:pPr indent="0" marL="0">
+              <a:lnSpc>
+                <a:spcPct val="105000"/>
+              </a:lnSpc>
+              <a:buNone/>
+            </a:pPr>
+            <a:r>
+              <a:rPr lang="en-US" sz="1400" dirty="0">
+                <a:solidFill>
+                  <a:srgbClr val="5A6072"/>
+                </a:solidFill>
+                <a:latin typeface="Calibri" pitchFamily="34" charset="0"/>
+                <a:ea typeface="Calibri" pitchFamily="34" charset="-122"/>
+                <a:cs typeface="Calibri" pitchFamily="34" charset="-120"/>
+              </a:rPr>
+              <a:t>사내(Nexus) 보드 전제 → AXI wrapper·XDC 직접 작성으로 대응.</a:t>
+            </a:r>
+            <a:endParaRPr lang="en-US" sz="1400" dirty="0"/>
+          </a:p>
+        </p:txBody>
+      </p:sp>
+    </p:spTree>
+  </p:cSld>
+  <p:clrMapOvr>
+    <a:masterClrMapping/>
+  </p:clrMapOvr>
+</p:sld>
+</file>
+
+<file path=ppt/slides/slide11.xml><?xml version="1.0" encoding="utf-8"?>
+<p:sld xmlns:a="http://schemas.openxmlformats.org/drawingml/2006/main" xmlns:r="http://schemas.openxmlformats.org/officeDocument/2006/relationships" xmlns:p="http://schemas.openxmlformats.org/presentationml/2006/main">
+  <p:cSld name="Slide 11">
+    <p:bg>
+      <p:bgPr>
+        <a:solidFill>
           <a:srgbClr val="1A1F3D"/>
         </a:solidFill>
       </p:bgPr>
@@ -2320,7 +3439,7 @@
                 <a:ea typeface="Calibri" pitchFamily="34" charset="-122"/>
                 <a:cs typeface="Calibri" pitchFamily="34" charset="-120"/>
               </a:rPr>
-              <a:t>베어메탈에서 신경망 완전연결층 추론까지 end-to-end 동작, SD 독립 부팅 확보</a:t>
+              <a:t>베어메탈에서 MNIST 손글씨 인식까지 end-to-end 동작 (int8, 10/10 정확), SD 독립 부팅</a:t>
             </a:r>
             <a:endParaRPr lang="en-US" sz="1700" dirty="0"/>
           </a:p>
@@ -6666,7 +7785,7 @@
                 <a:ea typeface="Cambria" pitchFamily="34" charset="-122"/>
                 <a:cs typeface="Cambria" pitchFamily="34" charset="-120"/>
               </a:rPr>
-              <a:t>핵심 결과: NPU가 신경망 층을 계산</a:t>
+              <a:t>최종 데모: NPU가 손글씨를 읽는다</a:t>
             </a:r>
             <a:endParaRPr lang="en-US" sz="3100" dirty="0"/>
           </a:p>
@@ -6680,8 +7799,8 @@
         </p:nvSpPr>
         <p:spPr>
           <a:xfrm>
-            <a:off x="640080" y="1600200"/>
-            <a:ext cx="6400800" cy="548640"/>
+            <a:off x="640080" y="1572768"/>
+            <a:ext cx="7315200" cy="457200"/>
           </a:xfrm>
           <a:prstGeom prst="rect">
             <a:avLst/>
@@ -6697,17 +7816,17 @@
               <a:buNone/>
             </a:pPr>
             <a:r>
-              <a:rPr lang="en-US" sz="2200" b="1" dirty="0">
+              <a:rPr lang="en-US" sz="1600" dirty="0">
                 <a:solidFill>
                   <a:srgbClr val="F9E795"/>
                 </a:solidFill>
-                <a:latin typeface="Courier New" pitchFamily="34" charset="0"/>
-                <a:ea typeface="Courier New" pitchFamily="34" charset="-122"/>
-                <a:cs typeface="Courier New" pitchFamily="34" charset="-120"/>
-              </a:rPr>
-              <a:t>Y = ReLU( W · X + b )</a:t>
-            </a:r>
-            <a:endParaRPr lang="en-US" sz="2200" dirty="0"/>
+                <a:latin typeface="Calibri" pitchFamily="34" charset="0"/>
+                <a:ea typeface="Calibri" pitchFamily="34" charset="-122"/>
+                <a:cs typeface="Calibri" pitchFamily="34" charset="-120"/>
+              </a:rPr>
+              <a:t>MNIST 8x8 · 학습된 MLP(64-32-10) · int8 양자화 추론</a:t>
+            </a:r>
+            <a:endParaRPr lang="en-US" sz="1600" dirty="0"/>
           </a:p>
         </p:txBody>
       </p:sp>
@@ -6719,12 +7838,12 @@
         </p:nvSpPr>
         <p:spPr>
           <a:xfrm>
-            <a:off x="640080" y="2331720"/>
-            <a:ext cx="6766560" cy="3840480"/>
+            <a:off x="640080" y="2194560"/>
+            <a:ext cx="5943600" cy="4023360"/>
           </a:xfrm>
           <a:prstGeom prst="roundRect">
             <a:avLst>
-              <a:gd name="adj" fmla="val 1429"/>
+              <a:gd name="adj" fmla="val 1364"/>
             </a:avLst>
           </a:prstGeom>
           <a:solidFill>
@@ -6746,8 +7865,8 @@
         </p:nvSpPr>
         <p:spPr>
           <a:xfrm>
-            <a:off x="868680" y="2514600"/>
-            <a:ext cx="6309360" cy="3474720"/>
+            <a:off x="868680" y="2377440"/>
+            <a:ext cx="5486400" cy="3657600"/>
           </a:xfrm>
           <a:prstGeom prst="rect">
             <a:avLst/>
@@ -6761,12 +7880,12 @@
           <a:p>
             <a:pPr indent="0" marL="0">
               <a:lnSpc>
-                <a:spcPct val="115000"/>
+                <a:spcPct val="112000"/>
               </a:lnSpc>
               <a:buNone/>
             </a:pPr>
             <a:r>
-              <a:rPr lang="en-US" sz="1250" dirty="0">
+              <a:rPr lang="en-US" sz="1100" dirty="0">
                 <a:solidFill>
                   <a:srgbClr val="9EF0C0"/>
                 </a:solidFill>
@@ -6774,19 +7893,19 @@
                 <a:ea typeface="Courier New" pitchFamily="34" charset="-122"/>
                 <a:cs typeface="Courier New" pitchFamily="34" charset="-120"/>
               </a:rPr>
-              <a:t>=== Coral NPU: Fully-Connected Layer ===</a:t>
-            </a:r>
-            <a:endParaRPr lang="en-US" sz="1250" dirty="0"/>
+              <a:t>      ==@@%%==        ::**@@@@::</a:t>
+            </a:r>
+            <a:endParaRPr lang="en-US" sz="1100" dirty="0"/>
           </a:p>
           <a:p>
             <a:pPr indent="0" marL="0">
               <a:lnSpc>
-                <a:spcPct val="115000"/>
+                <a:spcPct val="112000"/>
               </a:lnSpc>
               <a:buNone/>
             </a:pPr>
             <a:r>
-              <a:rPr lang="en-US" sz="1250" dirty="0">
+              <a:rPr lang="en-US" sz="1100" dirty="0">
                 <a:solidFill>
                   <a:srgbClr val="9EF0C0"/>
                 </a:solidFill>
@@ -6794,19 +7913,19 @@
                 <a:ea typeface="Courier New" pitchFamily="34" charset="-122"/>
                 <a:cs typeface="Courier New" pitchFamily="34" charset="-120"/>
               </a:rPr>
-              <a:t>W = [[ 1 -2  0  3],[ 2  1 -1  0],</a:t>
-            </a:r>
-            <a:endParaRPr lang="en-US" sz="1250" dirty="0"/>
+              <a:t>      @@@@@@..      ..%%**++@@::</a:t>
+            </a:r>
+            <a:endParaRPr lang="en-US" sz="1100" dirty="0"/>
           </a:p>
           <a:p>
             <a:pPr indent="0" marL="0">
               <a:lnSpc>
-                <a:spcPct val="115000"/>
+                <a:spcPct val="112000"/>
               </a:lnSpc>
               <a:buNone/>
             </a:pPr>
             <a:r>
-              <a:rPr lang="en-US" sz="1250" dirty="0">
+              <a:rPr lang="en-US" sz="1100" dirty="0">
                 <a:solidFill>
                   <a:srgbClr val="9EF0C0"/>
                 </a:solidFill>
@@ -6814,19 +7933,19 @@
                 <a:ea typeface="Courier New" pitchFamily="34" charset="-122"/>
                 <a:cs typeface="Courier New" pitchFamily="34" charset="-120"/>
               </a:rPr>
-              <a:t>     [ 0  0  2  1],[-1  4  1  2]]</a:t>
-            </a:r>
-            <a:endParaRPr lang="en-US" sz="1250" dirty="0"/>
+              <a:t>    ..@@@@++          ::  ++##</a:t>
+            </a:r>
+            <a:endParaRPr lang="en-US" sz="1100" dirty="0"/>
           </a:p>
           <a:p>
             <a:pPr indent="0" marL="0">
               <a:lnSpc>
-                <a:spcPct val="115000"/>
+                <a:spcPct val="112000"/>
               </a:lnSpc>
               <a:buNone/>
             </a:pPr>
             <a:r>
-              <a:rPr lang="en-US" sz="1250" dirty="0">
+              <a:rPr lang="en-US" sz="1100" dirty="0">
                 <a:solidFill>
                   <a:srgbClr val="9EF0C0"/>
                 </a:solidFill>
@@ -6834,28 +7953,19 @@
                 <a:ea typeface="Courier New" pitchFamily="34" charset="-122"/>
                 <a:cs typeface="Courier New" pitchFamily="34" charset="-120"/>
               </a:rPr>
-              <a:t>X = [3 1 2 5]   b = [0 -50 1 100]</a:t>
-            </a:r>
-            <a:endParaRPr lang="en-US" sz="1250" dirty="0"/>
+              <a:t>    ..@@@@**          --%%@@@@**</a:t>
+            </a:r>
+            <a:endParaRPr lang="en-US" sz="1100" dirty="0"/>
           </a:p>
           <a:p>
             <a:pPr indent="0" marL="0">
               <a:lnSpc>
-                <a:spcPct val="115000"/>
+                <a:spcPct val="112000"/>
               </a:lnSpc>
               <a:buNone/>
             </a:pPr>
-            <a:endParaRPr lang="en-US" sz="1250" dirty="0"/>
-          </a:p>
-          <a:p>
-            <a:pPr indent="0" marL="0">
-              <a:lnSpc>
-                <a:spcPct val="115000"/>
-              </a:lnSpc>
-              <a:buNone/>
-            </a:pPr>
-            <a:r>
-              <a:rPr lang="en-US" sz="1250" dirty="0">
+            <a:r>
+              <a:rPr lang="en-US" sz="1100" dirty="0">
                 <a:solidFill>
                   <a:srgbClr val="9EF0C0"/>
                 </a:solidFill>
@@ -6863,19 +7973,19 @@
                 <a:ea typeface="Courier New" pitchFamily="34" charset="-122"/>
                 <a:cs typeface="Courier New" pitchFamily="34" charset="-120"/>
               </a:rPr>
-              <a:t>NPU  Y = [ 16  0  10  113 ]</a:t>
-            </a:r>
-            <a:endParaRPr lang="en-US" sz="1250" dirty="0"/>
+              <a:t>    --@@@@##          ++@@##::</a:t>
+            </a:r>
+            <a:endParaRPr lang="en-US" sz="1100" dirty="0"/>
           </a:p>
           <a:p>
             <a:pPr indent="0" marL="0">
               <a:lnSpc>
-                <a:spcPct val="115000"/>
+                <a:spcPct val="112000"/>
               </a:lnSpc>
               <a:buNone/>
             </a:pPr>
             <a:r>
-              <a:rPr lang="en-US" sz="1250" dirty="0">
+              <a:rPr lang="en-US" sz="1100" dirty="0">
                 <a:solidFill>
                   <a:srgbClr val="9EF0C0"/>
                 </a:solidFill>
@@ -6883,19 +7993,19 @@
                 <a:ea typeface="Courier New" pitchFamily="34" charset="-122"/>
                 <a:cs typeface="Courier New" pitchFamily="34" charset="-120"/>
               </a:rPr>
-              <a:t>  Y[0]=16  OK   Y[1]=0  OK (ReLU)</a:t>
-            </a:r>
-            <a:endParaRPr lang="en-US" sz="1250" dirty="0"/>
+              <a:t>      @@@@**            ##--</a:t>
+            </a:r>
+            <a:endParaRPr lang="en-US" sz="1100" dirty="0"/>
           </a:p>
           <a:p>
             <a:pPr indent="0" marL="0">
               <a:lnSpc>
-                <a:spcPct val="115000"/>
+                <a:spcPct val="112000"/>
               </a:lnSpc>
               <a:buNone/>
             </a:pPr>
             <a:r>
-              <a:rPr lang="en-US" sz="1250" dirty="0">
+              <a:rPr lang="en-US" sz="1100" dirty="0">
                 <a:solidFill>
                   <a:srgbClr val="9EF0C0"/>
                 </a:solidFill>
@@ -6903,19 +8013,19 @@
                 <a:ea typeface="Courier New" pitchFamily="34" charset="-122"/>
                 <a:cs typeface="Courier New" pitchFamily="34" charset="-120"/>
               </a:rPr>
-              <a:t>  Y[2]=10  OK   Y[3]=113 OK</a:t>
-            </a:r>
-            <a:endParaRPr lang="en-US" sz="1250" dirty="0"/>
+              <a:t>      @@@@++          ::@@::</a:t>
+            </a:r>
+            <a:endParaRPr lang="en-US" sz="1100" dirty="0"/>
           </a:p>
           <a:p>
             <a:pPr indent="0" marL="0">
               <a:lnSpc>
-                <a:spcPct val="115000"/>
+                <a:spcPct val="112000"/>
               </a:lnSpc>
               <a:buNone/>
             </a:pPr>
             <a:r>
-              <a:rPr lang="en-US" sz="1250" dirty="0">
+              <a:rPr lang="en-US" sz="1100" dirty="0">
                 <a:solidFill>
                   <a:srgbClr val="9EF0C0"/>
                 </a:solidFill>
@@ -6923,9 +8033,87 @@
                 <a:ea typeface="Courier New" pitchFamily="34" charset="-122"/>
                 <a:cs typeface="Courier New" pitchFamily="34" charset="-120"/>
               </a:rPr>
-              <a:t>RESULT: PASS</a:t>
-            </a:r>
-            <a:endParaRPr lang="en-US" sz="1250" dirty="0"/>
+              <a:t>      --%%%%          ==@@</a:t>
+            </a:r>
+            <a:endParaRPr lang="en-US" sz="1100" dirty="0"/>
+          </a:p>
+          <a:p>
+            <a:pPr indent="0" marL="0">
+              <a:lnSpc>
+                <a:spcPct val="112000"/>
+              </a:lnSpc>
+              <a:buNone/>
+            </a:pPr>
+            <a:endParaRPr lang="en-US" sz="1100" dirty="0"/>
+          </a:p>
+          <a:p>
+            <a:pPr indent="0" marL="0">
+              <a:lnSpc>
+                <a:spcPct val="112000"/>
+              </a:lnSpc>
+              <a:buNone/>
+            </a:pPr>
+            <a:r>
+              <a:rPr lang="en-US" sz="1100" dirty="0">
+                <a:solidFill>
+                  <a:srgbClr val="9EF0C0"/>
+                </a:solidFill>
+                <a:latin typeface="Courier New" pitchFamily="34" charset="0"/>
+                <a:ea typeface="Courier New" pitchFamily="34" charset="-122"/>
+                <a:cs typeface="Courier New" pitchFamily="34" charset="-120"/>
+              </a:rPr>
+              <a:t>   NPU -&gt; 1  (label 1) OK</a:t>
+            </a:r>
+            <a:endParaRPr lang="en-US" sz="1100" dirty="0"/>
+          </a:p>
+          <a:p>
+            <a:pPr indent="0" marL="0">
+              <a:lnSpc>
+                <a:spcPct val="112000"/>
+              </a:lnSpc>
+              <a:buNone/>
+            </a:pPr>
+            <a:r>
+              <a:rPr lang="en-US" sz="1100" dirty="0">
+                <a:solidFill>
+                  <a:srgbClr val="9EF0C0"/>
+                </a:solidFill>
+                <a:latin typeface="Courier New" pitchFamily="34" charset="0"/>
+                <a:ea typeface="Courier New" pitchFamily="34" charset="-122"/>
+                <a:cs typeface="Courier New" pitchFamily="34" charset="-120"/>
+              </a:rPr>
+              <a:t>   NPU -&gt; 7  (label 7) OK</a:t>
+            </a:r>
+            <a:endParaRPr lang="en-US" sz="1100" dirty="0"/>
+          </a:p>
+          <a:p>
+            <a:pPr indent="0" marL="0">
+              <a:lnSpc>
+                <a:spcPct val="112000"/>
+              </a:lnSpc>
+              <a:buNone/>
+            </a:pPr>
+            <a:endParaRPr lang="en-US" sz="1100" dirty="0"/>
+          </a:p>
+          <a:p>
+            <a:pPr indent="0" marL="0">
+              <a:lnSpc>
+                <a:spcPct val="112000"/>
+              </a:lnSpc>
+              <a:buNone/>
+            </a:pPr>
+            <a:r>
+              <a:rPr lang="en-US" sz="1100" dirty="0">
+                <a:solidFill>
+                  <a:srgbClr val="9EF0C0"/>
+                </a:solidFill>
+                <a:latin typeface="Courier New" pitchFamily="34" charset="0"/>
+                <a:ea typeface="Courier New" pitchFamily="34" charset="-122"/>
+                <a:cs typeface="Courier New" pitchFamily="34" charset="-120"/>
+              </a:rPr>
+              <a:t>   ===== 10 / 10 correct =====</a:t>
+            </a:r>
+            <a:endParaRPr lang="en-US" sz="1100" dirty="0"/>
           </a:p>
         </p:txBody>
       </p:sp>
@@ -6937,12 +8125,12 @@
         </p:nvSpPr>
         <p:spPr>
           <a:xfrm>
-            <a:off x="7955280" y="2331720"/>
-            <a:ext cx="3566160" cy="1828800"/>
+            <a:off x="7086600" y="2194560"/>
+            <a:ext cx="4434840" cy="1600200"/>
           </a:xfrm>
           <a:prstGeom prst="roundRect">
             <a:avLst>
-              <a:gd name="adj" fmla="val 5000"/>
+              <a:gd name="adj" fmla="val 5714"/>
             </a:avLst>
           </a:prstGeom>
           <a:solidFill>
@@ -6959,8 +8147,8 @@
         </p:nvSpPr>
         <p:spPr>
           <a:xfrm>
-            <a:off x="7955280" y="2514600"/>
-            <a:ext cx="3566160" cy="914400"/>
+            <a:off x="7086600" y="2377440"/>
+            <a:ext cx="4434840" cy="868680"/>
           </a:xfrm>
           <a:prstGeom prst="rect">
             <a:avLst/>
@@ -6976,7 +8164,7 @@
               <a:buNone/>
             </a:pPr>
             <a:r>
-              <a:rPr lang="en-US" sz="4400" b="1" dirty="0">
+              <a:rPr lang="en-US" sz="4200" b="1" dirty="0">
                 <a:solidFill>
                   <a:srgbClr val="FFFFFF"/>
                 </a:solidFill>
@@ -6984,9 +8172,9 @@
                 <a:ea typeface="Cambria" pitchFamily="34" charset="-122"/>
                 <a:cs typeface="Cambria" pitchFamily="34" charset="-120"/>
               </a:rPr>
-              <a:t>PASS</a:t>
-            </a:r>
-            <a:endParaRPr lang="en-US" sz="4400" dirty="0"/>
+              <a:t>10 / 10</a:t>
+            </a:r>
+            <a:endParaRPr lang="en-US" sz="4200" dirty="0"/>
           </a:p>
         </p:txBody>
       </p:sp>
@@ -6998,8 +8186,8 @@
         </p:nvSpPr>
         <p:spPr>
           <a:xfrm>
-            <a:off x="7955280" y="3429000"/>
-            <a:ext cx="3566160" cy="548640"/>
+            <a:off x="7086600" y="3246120"/>
+            <a:ext cx="4434840" cy="457200"/>
           </a:xfrm>
           <a:prstGeom prst="rect">
             <a:avLst/>
@@ -7023,7 +8211,7 @@
                 <a:ea typeface="Calibri" pitchFamily="34" charset="-122"/>
                 <a:cs typeface="Calibri" pitchFamily="34" charset="-120"/>
               </a:rPr>
-              <a:t>SD 부팅만으로 자동 실행</a:t>
+              <a:t>0~9 손글씨 전부 정확 인식</a:t>
             </a:r>
             <a:endParaRPr lang="en-US" sz="1400" dirty="0"/>
           </a:p>
@@ -7037,8 +8225,8 @@
         </p:nvSpPr>
         <p:spPr>
           <a:xfrm>
-            <a:off x="7955280" y="4480560"/>
-            <a:ext cx="3611880" cy="1554480"/>
+            <a:off x="7132320" y="4069080"/>
+            <a:ext cx="4389120" cy="2103120"/>
           </a:xfrm>
           <a:prstGeom prst="rect">
             <a:avLst/>
@@ -7052,13 +8240,13 @@
           <a:p>
             <a:pPr marL="342900" indent="-342900">
               <a:spcAft>
-                <a:spcPts val="800"/>
+                <a:spcPts val="1000"/>
               </a:spcAft>
               <a:buSzPct val="100000"/>
               <a:buChar char="•"/>
             </a:pPr>
             <a:r>
-              <a:rPr lang="en-US" sz="1400" dirty="0">
+              <a:rPr lang="en-US" sz="1450" dirty="0">
                 <a:solidFill>
                   <a:srgbClr val="C9D0E8"/>
                 </a:solidFill>
@@ -7066,20 +8254,20 @@
                 <a:ea typeface="Calibri" pitchFamily="34" charset="-122"/>
                 <a:cs typeface="Calibri" pitchFamily="34" charset="-120"/>
               </a:rPr>
-              <a:t>행렬곱 + 편향 + ReLU = 완전연결층 1개</a:t>
-            </a:r>
-            <a:endParaRPr lang="en-US" sz="1400" dirty="0"/>
+              <a:t>학습된 모델 (scikit-learn digits)</a:t>
+            </a:r>
+            <a:endParaRPr lang="en-US" sz="1450" dirty="0"/>
           </a:p>
           <a:p>
             <a:pPr marL="342900" indent="-342900">
               <a:spcAft>
-                <a:spcPts val="800"/>
+                <a:spcPts val="1000"/>
               </a:spcAft>
               <a:buSzPct val="100000"/>
               <a:buChar char="•"/>
             </a:pPr>
             <a:r>
-              <a:rPr lang="en-US" sz="1400" dirty="0">
+              <a:rPr lang="en-US" sz="1450" dirty="0">
                 <a:solidFill>
                   <a:srgbClr val="C9D0E8"/>
                 </a:solidFill>
@@ -7087,9 +8275,51 @@
                 <a:ea typeface="Calibri" pitchFamily="34" charset="-122"/>
                 <a:cs typeface="Calibri" pitchFamily="34" charset="-120"/>
               </a:rPr>
-              <a:t>컴퓨터·JTAG 없이 보드 전원만으로 동작</a:t>
-            </a:r>
-            <a:endParaRPr lang="en-US" sz="1400" dirty="0"/>
+              <a:t>int8 정수 연산만으로 추론</a:t>
+            </a:r>
+            <a:endParaRPr lang="en-US" sz="1450" dirty="0"/>
+          </a:p>
+          <a:p>
+            <a:pPr marL="342900" indent="-342900">
+              <a:spcAft>
+                <a:spcPts val="1000"/>
+              </a:spcAft>
+              <a:buSzPct val="100000"/>
+              <a:buChar char="•"/>
+            </a:pPr>
+            <a:r>
+              <a:rPr lang="en-US" sz="1450" dirty="0">
+                <a:solidFill>
+                  <a:srgbClr val="C9D0E8"/>
+                </a:solidFill>
+                <a:latin typeface="Calibri" pitchFamily="34" charset="0"/>
+                <a:ea typeface="Calibri" pitchFamily="34" charset="-122"/>
+                <a:cs typeface="Calibri" pitchFamily="34" charset="-120"/>
+              </a:rPr>
+              <a:t>C 작성 → riscv gcc(rv32im) 빌드</a:t>
+            </a:r>
+            <a:endParaRPr lang="en-US" sz="1450" dirty="0"/>
+          </a:p>
+          <a:p>
+            <a:pPr marL="342900" indent="-342900">
+              <a:spcAft>
+                <a:spcPts val="1000"/>
+              </a:spcAft>
+              <a:buSzPct val="100000"/>
+              <a:buChar char="•"/>
+            </a:pPr>
+            <a:r>
+              <a:rPr lang="en-US" sz="1450" dirty="0">
+                <a:solidFill>
+                  <a:srgbClr val="C9D0E8"/>
+                </a:solidFill>
+                <a:latin typeface="Calibri" pitchFamily="34" charset="0"/>
+                <a:ea typeface="Calibri" pitchFamily="34" charset="-122"/>
+                <a:cs typeface="Calibri" pitchFamily="34" charset="-120"/>
+              </a:rPr>
+              <a:t>SD 부팅만으로 자동 실행</a:t>
+            </a:r>
+            <a:endParaRPr lang="en-US" sz="1450" dirty="0"/>
           </a:p>
         </p:txBody>
       </p:sp>
@@ -7158,7 +8388,7 @@
                 <a:ea typeface="Calibri" pitchFamily="34" charset="-122"/>
                 <a:cs typeface="Calibri" pitchFamily="34" charset="-120"/>
               </a:rPr>
-              <a:t>PERFORMANCE</a:t>
+              <a:t>QUANTIZATION</a:t>
             </a:r>
             <a:endParaRPr lang="en-US" sz="1200" dirty="0"/>
           </a:p>
@@ -7173,7 +8403,7 @@
         <p:spPr>
           <a:xfrm>
             <a:off x="594360" y="777240"/>
-            <a:ext cx="10058400" cy="731520"/>
+            <a:ext cx="10972800" cy="731520"/>
           </a:xfrm>
           <a:prstGeom prst="rect">
             <a:avLst/>
@@ -7189,7 +8419,7 @@
               <a:buNone/>
             </a:pPr>
             <a:r>
-              <a:rPr lang="en-US" sz="3400" b="1" dirty="0">
+              <a:rPr lang="en-US" sz="3100" b="1" dirty="0">
                 <a:solidFill>
                   <a:srgbClr val="1A1F3D"/>
                 </a:solidFill>
@@ -7197,9 +8427,9 @@
                 <a:ea typeface="Cambria" pitchFamily="34" charset="-122"/>
                 <a:cs typeface="Cambria" pitchFamily="34" charset="-120"/>
               </a:rPr>
-              <a:t>성능 · 리소스 사용량</a:t>
-            </a:r>
-            <a:endParaRPr lang="en-US" sz="3400" dirty="0"/>
+              <a:t>int8 양자화: 정확도는 그대로, 메모리는 1/4</a:t>
+            </a:r>
+            <a:endParaRPr lang="en-US" sz="3100" dirty="0"/>
           </a:p>
         </p:txBody>
       </p:sp>
@@ -7211,8 +8441,8 @@
         </p:nvSpPr>
         <p:spPr>
           <a:xfrm>
-            <a:off x="685800" y="1737360"/>
-            <a:ext cx="3383280" cy="822960"/>
+            <a:off x="685800" y="1783080"/>
+            <a:ext cx="3383280" cy="868680"/>
           </a:xfrm>
           <a:prstGeom prst="rect">
             <a:avLst/>
@@ -7228,7 +8458,7 @@
               <a:buNone/>
             </a:pPr>
             <a:r>
-              <a:rPr lang="en-US" sz="4400" b="1" dirty="0">
+              <a:rPr lang="en-US" sz="4200" b="1" dirty="0">
                 <a:solidFill>
                   <a:srgbClr val="F96167"/>
                 </a:solidFill>
@@ -7236,9 +8466,9 @@
                 <a:ea typeface="Cambria" pitchFamily="34" charset="-122"/>
                 <a:cs typeface="Cambria" pitchFamily="34" charset="-120"/>
               </a:rPr>
-              <a:t>18.6%</a:t>
-            </a:r>
-            <a:endParaRPr lang="en-US" sz="4400" dirty="0"/>
+              <a:t>98.00%</a:t>
+            </a:r>
+            <a:endParaRPr lang="en-US" sz="4200" dirty="0"/>
           </a:p>
         </p:txBody>
       </p:sp>
@@ -7250,7 +8480,7 @@
         </p:nvSpPr>
         <p:spPr>
           <a:xfrm>
-            <a:off x="685800" y="2606040"/>
+            <a:off x="685800" y="2697480"/>
             <a:ext cx="3383280" cy="365760"/>
           </a:xfrm>
           <a:prstGeom prst="rect">
@@ -7275,7 +8505,7 @@
                 <a:ea typeface="Calibri" pitchFamily="34" charset="-122"/>
                 <a:cs typeface="Calibri" pitchFamily="34" charset="-120"/>
               </a:rPr>
-              <a:t>LUT 사용 (51,105)</a:t>
+              <a:t>float32 정확도</a:t>
             </a:r>
             <a:endParaRPr lang="en-US" sz="1400" dirty="0"/>
           </a:p>
@@ -7289,8 +8519,8 @@
         </p:nvSpPr>
         <p:spPr>
           <a:xfrm>
-            <a:off x="4343400" y="1737360"/>
-            <a:ext cx="3383280" cy="822960"/>
+            <a:off x="4343400" y="1783080"/>
+            <a:ext cx="3383280" cy="868680"/>
           </a:xfrm>
           <a:prstGeom prst="rect">
             <a:avLst/>
@@ -7306,7 +8536,7 @@
               <a:buNone/>
             </a:pPr>
             <a:r>
-              <a:rPr lang="en-US" sz="4400" b="1" dirty="0">
+              <a:rPr lang="en-US" sz="4200" b="1" dirty="0">
                 <a:solidFill>
                   <a:srgbClr val="F96167"/>
                 </a:solidFill>
@@ -7314,9 +8544,9 @@
                 <a:ea typeface="Cambria" pitchFamily="34" charset="-122"/>
                 <a:cs typeface="Cambria" pitchFamily="34" charset="-120"/>
               </a:rPr>
-              <a:t>541</a:t>
-            </a:r>
-            <a:endParaRPr lang="en-US" sz="4400" dirty="0"/>
+              <a:t>98.00%</a:t>
+            </a:r>
+            <a:endParaRPr lang="en-US" sz="4200" dirty="0"/>
           </a:p>
         </p:txBody>
       </p:sp>
@@ -7328,7 +8558,7 @@
         </p:nvSpPr>
         <p:spPr>
           <a:xfrm>
-            <a:off x="4343400" y="2606040"/>
+            <a:off x="4343400" y="2697480"/>
             <a:ext cx="3383280" cy="365760"/>
           </a:xfrm>
           <a:prstGeom prst="rect">
@@ -7353,7 +8583,7 @@
                 <a:ea typeface="Calibri" pitchFamily="34" charset="-122"/>
                 <a:cs typeface="Calibri" pitchFamily="34" charset="-120"/>
               </a:rPr>
-              <a:t>FC 1회 실행 명령어</a:t>
+              <a:t>int8 정확도 (손실 0)</a:t>
             </a:r>
             <a:endParaRPr lang="en-US" sz="1400" dirty="0"/>
           </a:p>
@@ -7367,8 +8597,8 @@
         </p:nvSpPr>
         <p:spPr>
           <a:xfrm>
-            <a:off x="8001000" y="1737360"/>
-            <a:ext cx="3383280" cy="822960"/>
+            <a:off x="8001000" y="1783080"/>
+            <a:ext cx="3383280" cy="868680"/>
           </a:xfrm>
           <a:prstGeom prst="rect">
             <a:avLst/>
@@ -7384,17 +8614,17 @@
               <a:buNone/>
             </a:pPr>
             <a:r>
-              <a:rPr lang="en-US" sz="4400" b="1" dirty="0">
-                <a:solidFill>
-                  <a:srgbClr val="F96167"/>
+              <a:rPr lang="en-US" sz="4200" b="1" dirty="0">
+                <a:solidFill>
+                  <a:srgbClr val="2F3C7E"/>
                 </a:solidFill>
                 <a:latin typeface="Cambria" pitchFamily="34" charset="0"/>
                 <a:ea typeface="Cambria" pitchFamily="34" charset="-122"/>
                 <a:cs typeface="Cambria" pitchFamily="34" charset="-120"/>
               </a:rPr>
-              <a:t>50 MHz</a:t>
-            </a:r>
-            <a:endParaRPr lang="en-US" sz="4400" dirty="0"/>
+              <a:t>4.0x</a:t>
+            </a:r>
+            <a:endParaRPr lang="en-US" sz="4200" dirty="0"/>
           </a:p>
         </p:txBody>
       </p:sp>
@@ -7406,7 +8636,7 @@
         </p:nvSpPr>
         <p:spPr>
           <a:xfrm>
-            <a:off x="8001000" y="2606040"/>
+            <a:off x="8001000" y="2697480"/>
             <a:ext cx="3383280" cy="365760"/>
           </a:xfrm>
           <a:prstGeom prst="rect">
@@ -7431,7 +8661,7 @@
                 <a:ea typeface="Calibri" pitchFamily="34" charset="-122"/>
                 <a:cs typeface="Calibri" pitchFamily="34" charset="-120"/>
               </a:rPr>
-              <a:t>동작 클럭 (WNS +0.46)</a:t>
+              <a:t>가중치 메모리 절감</a:t>
             </a:r>
             <a:endParaRPr lang="en-US" sz="1400" dirty="0"/>
           </a:p>
@@ -7445,7 +8675,7 @@
         </p:nvSpPr>
         <p:spPr>
           <a:xfrm>
-            <a:off x="685800" y="3383280"/>
+            <a:off x="685800" y="3429000"/>
             <a:ext cx="5486400" cy="365760"/>
           </a:xfrm>
           <a:prstGeom prst="rect">
@@ -7470,7 +8700,7 @@
                 <a:ea typeface="Cambria" pitchFamily="34" charset="-122"/>
                 <a:cs typeface="Cambria" pitchFamily="34" charset="-120"/>
               </a:rPr>
-              <a:t>XCZU9EG 자원 사용률 (%)</a:t>
+              <a:t>가중치 메모리 (bytes)</a:t>
             </a:r>
             <a:endParaRPr lang="en-US" sz="1600" dirty="0"/>
           </a:p>
@@ -7483,8 +8713,8 @@
           <p:nvPr/>
         </p:nvGraphicFramePr>
         <p:xfrm>
-          <a:off x="685800" y="3794760"/>
-          <a:ext cx="5577840" cy="2468880"/>
+          <a:off x="685800" y="3840480"/>
+          <a:ext cx="5394960" cy="2377440"/>
         </p:xfrm>
         <a:graphic xmlns:a="http://schemas.openxmlformats.org/drawingml/2006/main">
           <a:graphicData uri="http://schemas.openxmlformats.org/drawingml/2006/chart">
@@ -7500,12 +8730,12 @@
         </p:nvSpPr>
         <p:spPr>
           <a:xfrm>
-            <a:off x="6583680" y="3383280"/>
-            <a:ext cx="4937760" cy="2880360"/>
+            <a:off x="6492240" y="3429000"/>
+            <a:ext cx="5029200" cy="2788920"/>
           </a:xfrm>
           <a:prstGeom prst="roundRect">
             <a:avLst>
-              <a:gd name="adj" fmla="val 3175"/>
+              <a:gd name="adj" fmla="val 3279"/>
             </a:avLst>
           </a:prstGeom>
           <a:solidFill>
@@ -7527,7 +8757,7 @@
         </p:nvSpPr>
         <p:spPr>
           <a:xfrm>
-            <a:off x="6858000" y="3611880"/>
+            <a:off x="6766560" y="3657600"/>
             <a:ext cx="4572000" cy="365760"/>
           </a:xfrm>
           <a:prstGeom prst="rect">
@@ -7552,7 +8782,7 @@
                 <a:ea typeface="Cambria" pitchFamily="34" charset="-122"/>
                 <a:cs typeface="Cambria" pitchFamily="34" charset="-120"/>
               </a:rPr>
-              <a:t>읽는 법</a:t>
+              <a:t>방법</a:t>
             </a:r>
             <a:endParaRPr lang="en-US" sz="1700" dirty="0"/>
           </a:p>
@@ -7566,8 +8796,8 @@
         </p:nvSpPr>
         <p:spPr>
           <a:xfrm>
-            <a:off x="6858000" y="4114800"/>
-            <a:ext cx="4572000" cy="2011680"/>
+            <a:off x="6766560" y="4160520"/>
+            <a:ext cx="4572000" cy="1920240"/>
           </a:xfrm>
           <a:prstGeom prst="rect">
             <a:avLst/>
@@ -7581,13 +8811,13 @@
           <a:p>
             <a:pPr marL="342900" indent="-342900">
               <a:spcAft>
-                <a:spcPts val="900"/>
+                <a:spcPts val="800"/>
               </a:spcAft>
               <a:buSzPct val="100000"/>
               <a:buChar char="•"/>
             </a:pPr>
             <a:r>
-              <a:rPr lang="en-US" sz="1400" dirty="0">
+              <a:rPr lang="en-US" sz="1350" dirty="0">
                 <a:solidFill>
                   <a:srgbClr val="5A6072"/>
                 </a:solidFill>
@@ -7595,20 +8825,20 @@
                 <a:ea typeface="Calibri" pitchFamily="34" charset="-122"/>
                 <a:cs typeface="Calibri" pitchFamily="34" charset="-120"/>
               </a:rPr>
-              <a:t>BRAM 10개 ≈ ITCM 8KB + DTCM 32KB (사양 일치)</a:t>
-            </a:r>
-            <a:endParaRPr lang="en-US" sz="1400" dirty="0"/>
+              <a:t>대칭 양자화: q = round(r / (max|r|/127))</a:t>
+            </a:r>
+            <a:endParaRPr lang="en-US" sz="1350" dirty="0"/>
           </a:p>
           <a:p>
             <a:pPr marL="342900" indent="-342900">
               <a:spcAft>
-                <a:spcPts val="900"/>
+                <a:spcPts val="800"/>
               </a:spcAft>
               <a:buSzPct val="100000"/>
               <a:buChar char="•"/>
             </a:pPr>
             <a:r>
-              <a:rPr lang="en-US" sz="1400" dirty="0">
+              <a:rPr lang="en-US" sz="1350" dirty="0">
                 <a:solidFill>
                   <a:srgbClr val="5A6072"/>
                 </a:solidFill>
@@ -7616,20 +8846,20 @@
                 <a:ea typeface="Calibri" pitchFamily="34" charset="-122"/>
                 <a:cs typeface="Calibri" pitchFamily="34" charset="-120"/>
               </a:rPr>
-              <a:t>DSP 6개뿐 → 곱셈이 DSP 아닌 LUT로 구현됨</a:t>
-            </a:r>
-            <a:endParaRPr lang="en-US" sz="1400" dirty="0"/>
+              <a:t>가중치·입력 int8, 누적은 int32</a:t>
+            </a:r>
+            <a:endParaRPr lang="en-US" sz="1350" dirty="0"/>
           </a:p>
           <a:p>
             <a:pPr marL="342900" indent="-342900">
               <a:spcAft>
-                <a:spcPts val="900"/>
+                <a:spcPts val="800"/>
               </a:spcAft>
               <a:buSzPct val="100000"/>
               <a:buChar char="•"/>
             </a:pPr>
             <a:r>
-              <a:rPr lang="en-US" sz="1400" dirty="0">
+              <a:rPr lang="en-US" sz="1350" dirty="0">
                 <a:solidFill>
                   <a:srgbClr val="5A6072"/>
                 </a:solidFill>
@@ -7637,9 +8867,30 @@
                 <a:ea typeface="Calibri" pitchFamily="34" charset="-122"/>
                 <a:cs typeface="Calibri" pitchFamily="34" charset="-120"/>
               </a:rPr>
-              <a:t>NPU 코어가 사용량 대부분 (18% 수준)</a:t>
-            </a:r>
-            <a:endParaRPr lang="en-US" sz="1400" dirty="0"/>
+              <a:t>층간 재양자화를 고정소수점으로: (a x 1792) &gt;&gt; 20</a:t>
+            </a:r>
+            <a:endParaRPr lang="en-US" sz="1350" dirty="0"/>
+          </a:p>
+          <a:p>
+            <a:pPr marL="342900" indent="-342900">
+              <a:spcAft>
+                <a:spcPts val="800"/>
+              </a:spcAft>
+              <a:buSzPct val="100000"/>
+              <a:buChar char="•"/>
+            </a:pPr>
+            <a:r>
+              <a:rPr lang="en-US" sz="1350" dirty="0">
+                <a:solidFill>
+                  <a:srgbClr val="5A6072"/>
+                </a:solidFill>
+                <a:latin typeface="Calibri" pitchFamily="34" charset="0"/>
+                <a:ea typeface="Calibri" pitchFamily="34" charset="-122"/>
+                <a:cs typeface="Calibri" pitchFamily="34" charset="-120"/>
+              </a:rPr>
+              <a:t>부동소수 연산 0회 — 정수만으로 추론</a:t>
+            </a:r>
+            <a:endParaRPr lang="en-US" sz="1350" dirty="0"/>
           </a:p>
         </p:txBody>
       </p:sp>
@@ -7708,7 +8959,7 @@
                 <a:ea typeface="Calibri" pitchFamily="34" charset="-122"/>
                 <a:cs typeface="Calibri" pitchFamily="34" charset="-120"/>
               </a:rPr>
-              <a:t>LIMITATIONS</a:t>
+              <a:t>PERFORMANCE</a:t>
             </a:r>
             <a:endParaRPr lang="en-US" sz="1200" dirty="0"/>
           </a:p>
@@ -7747,7 +8998,7 @@
                 <a:ea typeface="Cambria" pitchFamily="34" charset="-122"/>
                 <a:cs typeface="Cambria" pitchFamily="34" charset="-120"/>
               </a:rPr>
-              <a:t>한계 분석</a:t>
+              <a:t>성능 · 리소스 사용량</a:t>
             </a:r>
             <a:endParaRPr lang="en-US" sz="3400" dirty="0"/>
           </a:p>
@@ -7755,18 +9006,307 @@
       </p:sp>
       <p:sp>
         <p:nvSpPr>
-          <p:cNvPr id="4" name="Shape 2"/>
-          <p:cNvSpPr/>
-          <p:nvPr/>
-        </p:nvSpPr>
-        <p:spPr>
-          <a:xfrm>
-            <a:off x="640080" y="1783080"/>
-            <a:ext cx="5349240" cy="1874520"/>
+          <p:cNvPr id="4" name="Text 2"/>
+          <p:cNvSpPr/>
+          <p:nvPr/>
+        </p:nvSpPr>
+        <p:spPr>
+          <a:xfrm>
+            <a:off x="685800" y="1737360"/>
+            <a:ext cx="3383280" cy="822960"/>
+          </a:xfrm>
+          <a:prstGeom prst="rect">
+            <a:avLst/>
+          </a:prstGeom>
+          <a:noFill/>
+          <a:ln/>
+        </p:spPr>
+        <p:txBody>
+          <a:bodyPr wrap="square" lIns="0" tIns="0" rIns="0" bIns="0" rtlCol="0" anchor="ctr"/>
+          <a:lstStyle/>
+          <a:p>
+            <a:pPr indent="0" marL="0">
+              <a:buNone/>
+            </a:pPr>
+            <a:r>
+              <a:rPr lang="en-US" sz="4400" b="1" dirty="0">
+                <a:solidFill>
+                  <a:srgbClr val="F96167"/>
+                </a:solidFill>
+                <a:latin typeface="Cambria" pitchFamily="34" charset="0"/>
+                <a:ea typeface="Cambria" pitchFamily="34" charset="-122"/>
+                <a:cs typeface="Cambria" pitchFamily="34" charset="-120"/>
+              </a:rPr>
+              <a:t>18.6%</a:t>
+            </a:r>
+            <a:endParaRPr lang="en-US" sz="4400" dirty="0"/>
+          </a:p>
+        </p:txBody>
+      </p:sp>
+      <p:sp>
+        <p:nvSpPr>
+          <p:cNvPr id="5" name="Text 3"/>
+          <p:cNvSpPr/>
+          <p:nvPr/>
+        </p:nvSpPr>
+        <p:spPr>
+          <a:xfrm>
+            <a:off x="685800" y="2606040"/>
+            <a:ext cx="3383280" cy="365760"/>
+          </a:xfrm>
+          <a:prstGeom prst="rect">
+            <a:avLst/>
+          </a:prstGeom>
+          <a:noFill/>
+          <a:ln/>
+        </p:spPr>
+        <p:txBody>
+          <a:bodyPr wrap="square" lIns="0" tIns="0" rIns="0" bIns="0" rtlCol="0" anchor="ctr"/>
+          <a:lstStyle/>
+          <a:p>
+            <a:pPr indent="0" marL="0">
+              <a:buNone/>
+            </a:pPr>
+            <a:r>
+              <a:rPr lang="en-US" sz="1400" dirty="0">
+                <a:solidFill>
+                  <a:srgbClr val="5A6072"/>
+                </a:solidFill>
+                <a:latin typeface="Calibri" pitchFamily="34" charset="0"/>
+                <a:ea typeface="Calibri" pitchFamily="34" charset="-122"/>
+                <a:cs typeface="Calibri" pitchFamily="34" charset="-120"/>
+              </a:rPr>
+              <a:t>LUT 사용 (51,105)</a:t>
+            </a:r>
+            <a:endParaRPr lang="en-US" sz="1400" dirty="0"/>
+          </a:p>
+        </p:txBody>
+      </p:sp>
+      <p:sp>
+        <p:nvSpPr>
+          <p:cNvPr id="6" name="Text 4"/>
+          <p:cNvSpPr/>
+          <p:nvPr/>
+        </p:nvSpPr>
+        <p:spPr>
+          <a:xfrm>
+            <a:off x="4343400" y="1737360"/>
+            <a:ext cx="3383280" cy="822960"/>
+          </a:xfrm>
+          <a:prstGeom prst="rect">
+            <a:avLst/>
+          </a:prstGeom>
+          <a:noFill/>
+          <a:ln/>
+        </p:spPr>
+        <p:txBody>
+          <a:bodyPr wrap="square" lIns="0" tIns="0" rIns="0" bIns="0" rtlCol="0" anchor="ctr"/>
+          <a:lstStyle/>
+          <a:p>
+            <a:pPr indent="0" marL="0">
+              <a:buNone/>
+            </a:pPr>
+            <a:r>
+              <a:rPr lang="en-US" sz="4400" b="1" dirty="0">
+                <a:solidFill>
+                  <a:srgbClr val="F96167"/>
+                </a:solidFill>
+                <a:latin typeface="Cambria" pitchFamily="34" charset="0"/>
+                <a:ea typeface="Cambria" pitchFamily="34" charset="-122"/>
+                <a:cs typeface="Cambria" pitchFamily="34" charset="-120"/>
+              </a:rPr>
+              <a:t>345 us</a:t>
+            </a:r>
+            <a:endParaRPr lang="en-US" sz="4400" dirty="0"/>
+          </a:p>
+        </p:txBody>
+      </p:sp>
+      <p:sp>
+        <p:nvSpPr>
+          <p:cNvPr id="7" name="Text 5"/>
+          <p:cNvSpPr/>
+          <p:nvPr/>
+        </p:nvSpPr>
+        <p:spPr>
+          <a:xfrm>
+            <a:off x="4343400" y="2606040"/>
+            <a:ext cx="3383280" cy="365760"/>
+          </a:xfrm>
+          <a:prstGeom prst="rect">
+            <a:avLst/>
+          </a:prstGeom>
+          <a:noFill/>
+          <a:ln/>
+        </p:spPr>
+        <p:txBody>
+          <a:bodyPr wrap="square" lIns="0" tIns="0" rIns="0" bIns="0" rtlCol="0" anchor="ctr"/>
+          <a:lstStyle/>
+          <a:p>
+            <a:pPr indent="0" marL="0">
+              <a:buNone/>
+            </a:pPr>
+            <a:r>
+              <a:rPr lang="en-US" sz="1400" dirty="0">
+                <a:solidFill>
+                  <a:srgbClr val="5A6072"/>
+                </a:solidFill>
+                <a:latin typeface="Calibri" pitchFamily="34" charset="0"/>
+                <a:ea typeface="Calibri" pitchFamily="34" charset="-122"/>
+                <a:cs typeface="Calibri" pitchFamily="34" charset="-120"/>
+              </a:rPr>
+              <a:t>MNIST 추론 1회 (50MHz)</a:t>
+            </a:r>
+            <a:endParaRPr lang="en-US" sz="1400" dirty="0"/>
+          </a:p>
+        </p:txBody>
+      </p:sp>
+      <p:sp>
+        <p:nvSpPr>
+          <p:cNvPr id="8" name="Text 6"/>
+          <p:cNvSpPr/>
+          <p:nvPr/>
+        </p:nvSpPr>
+        <p:spPr>
+          <a:xfrm>
+            <a:off x="8001000" y="1737360"/>
+            <a:ext cx="3383280" cy="822960"/>
+          </a:xfrm>
+          <a:prstGeom prst="rect">
+            <a:avLst/>
+          </a:prstGeom>
+          <a:noFill/>
+          <a:ln/>
+        </p:spPr>
+        <p:txBody>
+          <a:bodyPr wrap="square" lIns="0" tIns="0" rIns="0" bIns="0" rtlCol="0" anchor="ctr"/>
+          <a:lstStyle/>
+          <a:p>
+            <a:pPr indent="0" marL="0">
+              <a:buNone/>
+            </a:pPr>
+            <a:r>
+              <a:rPr lang="en-US" sz="4400" b="1" dirty="0">
+                <a:solidFill>
+                  <a:srgbClr val="F96167"/>
+                </a:solidFill>
+                <a:latin typeface="Cambria" pitchFamily="34" charset="0"/>
+                <a:ea typeface="Cambria" pitchFamily="34" charset="-122"/>
+                <a:cs typeface="Cambria" pitchFamily="34" charset="-120"/>
+              </a:rPr>
+              <a:t>50 MHz</a:t>
+            </a:r>
+            <a:endParaRPr lang="en-US" sz="4400" dirty="0"/>
+          </a:p>
+        </p:txBody>
+      </p:sp>
+      <p:sp>
+        <p:nvSpPr>
+          <p:cNvPr id="9" name="Text 7"/>
+          <p:cNvSpPr/>
+          <p:nvPr/>
+        </p:nvSpPr>
+        <p:spPr>
+          <a:xfrm>
+            <a:off x="8001000" y="2606040"/>
+            <a:ext cx="3383280" cy="365760"/>
+          </a:xfrm>
+          <a:prstGeom prst="rect">
+            <a:avLst/>
+          </a:prstGeom>
+          <a:noFill/>
+          <a:ln/>
+        </p:spPr>
+        <p:txBody>
+          <a:bodyPr wrap="square" lIns="0" tIns="0" rIns="0" bIns="0" rtlCol="0" anchor="ctr"/>
+          <a:lstStyle/>
+          <a:p>
+            <a:pPr indent="0" marL="0">
+              <a:buNone/>
+            </a:pPr>
+            <a:r>
+              <a:rPr lang="en-US" sz="1400" dirty="0">
+                <a:solidFill>
+                  <a:srgbClr val="5A6072"/>
+                </a:solidFill>
+                <a:latin typeface="Calibri" pitchFamily="34" charset="0"/>
+                <a:ea typeface="Calibri" pitchFamily="34" charset="-122"/>
+                <a:cs typeface="Calibri" pitchFamily="34" charset="-120"/>
+              </a:rPr>
+              <a:t>동작 클럭 (WNS +0.46)</a:t>
+            </a:r>
+            <a:endParaRPr lang="en-US" sz="1400" dirty="0"/>
+          </a:p>
+        </p:txBody>
+      </p:sp>
+      <p:sp>
+        <p:nvSpPr>
+          <p:cNvPr id="10" name="Text 8"/>
+          <p:cNvSpPr/>
+          <p:nvPr/>
+        </p:nvSpPr>
+        <p:spPr>
+          <a:xfrm>
+            <a:off x="685800" y="3383280"/>
+            <a:ext cx="5486400" cy="365760"/>
+          </a:xfrm>
+          <a:prstGeom prst="rect">
+            <a:avLst/>
+          </a:prstGeom>
+          <a:noFill/>
+          <a:ln/>
+        </p:spPr>
+        <p:txBody>
+          <a:bodyPr wrap="square" lIns="0" tIns="0" rIns="0" bIns="0" rtlCol="0" anchor="ctr"/>
+          <a:lstStyle/>
+          <a:p>
+            <a:pPr indent="0" marL="0">
+              <a:buNone/>
+            </a:pPr>
+            <a:r>
+              <a:rPr lang="en-US" sz="1600" b="1" dirty="0">
+                <a:solidFill>
+                  <a:srgbClr val="1A1F3D"/>
+                </a:solidFill>
+                <a:latin typeface="Cambria" pitchFamily="34" charset="0"/>
+                <a:ea typeface="Cambria" pitchFamily="34" charset="-122"/>
+                <a:cs typeface="Cambria" pitchFamily="34" charset="-120"/>
+              </a:rPr>
+              <a:t>XCZU9EG 자원 사용률 (%)</a:t>
+            </a:r>
+            <a:endParaRPr lang="en-US" sz="1600" dirty="0"/>
+          </a:p>
+        </p:txBody>
+      </p:sp>
+      <p:graphicFrame>
+        <p:nvGraphicFramePr>
+          <p:cNvPr id="11" name="Chart 0" descr=""/>
+          <p:cNvGraphicFramePr/>
+          <p:nvPr/>
+        </p:nvGraphicFramePr>
+        <p:xfrm>
+          <a:off x="685800" y="3794760"/>
+          <a:ext cx="5577840" cy="2468880"/>
+        </p:xfrm>
+        <a:graphic xmlns:a="http://schemas.openxmlformats.org/drawingml/2006/main">
+          <a:graphicData uri="http://schemas.openxmlformats.org/drawingml/2006/chart">
+            <c:chart xmlns:c="http://schemas.openxmlformats.org/drawingml/2006/chart" r:id="rId1"/>
+          </a:graphicData>
+        </a:graphic>
+      </p:graphicFrame>
+      <p:sp>
+        <p:nvSpPr>
+          <p:cNvPr id="12" name="Shape 9"/>
+          <p:cNvSpPr/>
+          <p:nvPr/>
+        </p:nvSpPr>
+        <p:spPr>
+          <a:xfrm>
+            <a:off x="6583680" y="3383280"/>
+            <a:ext cx="4937760" cy="2880360"/>
           </a:xfrm>
           <a:prstGeom prst="roundRect">
             <a:avLst>
-              <a:gd name="adj" fmla="val 4878"/>
+              <a:gd name="adj" fmla="val 3175"/>
             </a:avLst>
           </a:prstGeom>
           <a:solidFill>
@@ -7778,139 +9318,74 @@
             </a:solidFill>
             <a:prstDash val="solid"/>
           </a:ln>
-          <a:effectLst>
-            <a:outerShdw sx="100000" sy="100000" kx="0" ky="0" algn="bl" rotWithShape="0" blurRad="101600" dist="25400" dir="5400000">
-              <a:srgbClr val="9099B0">
-                <a:alpha val="30000"/>
-              </a:srgbClr>
-            </a:outerShdw>
-          </a:effectLst>
-        </p:spPr>
-      </p:sp>
-      <p:sp>
-        <p:nvSpPr>
-          <p:cNvPr id="5" name="Shape 3"/>
-          <p:cNvSpPr/>
-          <p:nvPr/>
-        </p:nvSpPr>
-        <p:spPr>
-          <a:xfrm>
-            <a:off x="960120" y="2084832"/>
-            <a:ext cx="310896" cy="310896"/>
-          </a:xfrm>
-          <a:prstGeom prst="ellipse">
-            <a:avLst/>
-          </a:prstGeom>
-          <a:solidFill>
-            <a:srgbClr val="F96167"/>
-          </a:solidFill>
-          <a:ln/>
-        </p:spPr>
-      </p:sp>
-      <p:sp>
-        <p:nvSpPr>
-          <p:cNvPr id="6" name="Text 4"/>
-          <p:cNvSpPr/>
-          <p:nvPr/>
-        </p:nvSpPr>
-        <p:spPr>
-          <a:xfrm>
-            <a:off x="960120" y="2066544"/>
-            <a:ext cx="310896" cy="310896"/>
-          </a:xfrm>
-          <a:prstGeom prst="rect">
-            <a:avLst/>
-          </a:prstGeom>
-          <a:noFill/>
-          <a:ln/>
-        </p:spPr>
-        <p:txBody>
-          <a:bodyPr wrap="square" lIns="0" tIns="0" rIns="0" bIns="0" rtlCol="0" anchor="ctr"/>
-          <a:lstStyle/>
-          <a:p>
-            <a:pPr algn="ctr" indent="0" marL="0">
-              <a:buNone/>
-            </a:pPr>
-            <a:r>
-              <a:rPr lang="en-US" sz="1500" b="1" dirty="0">
-                <a:solidFill>
-                  <a:srgbClr val="FFFFFF"/>
+        </p:spPr>
+      </p:sp>
+      <p:sp>
+        <p:nvSpPr>
+          <p:cNvPr id="13" name="Text 10"/>
+          <p:cNvSpPr/>
+          <p:nvPr/>
+        </p:nvSpPr>
+        <p:spPr>
+          <a:xfrm>
+            <a:off x="6858000" y="3611880"/>
+            <a:ext cx="4572000" cy="365760"/>
+          </a:xfrm>
+          <a:prstGeom prst="rect">
+            <a:avLst/>
+          </a:prstGeom>
+          <a:noFill/>
+          <a:ln/>
+        </p:spPr>
+        <p:txBody>
+          <a:bodyPr wrap="square" lIns="0" tIns="0" rIns="0" bIns="0" rtlCol="0" anchor="ctr"/>
+          <a:lstStyle/>
+          <a:p>
+            <a:pPr indent="0" marL="0">
+              <a:buNone/>
+            </a:pPr>
+            <a:r>
+              <a:rPr lang="en-US" sz="1700" b="1" dirty="0">
+                <a:solidFill>
+                  <a:srgbClr val="2F3C7E"/>
                 </a:solidFill>
                 <a:latin typeface="Cambria" pitchFamily="34" charset="0"/>
                 <a:ea typeface="Cambria" pitchFamily="34" charset="-122"/>
                 <a:cs typeface="Cambria" pitchFamily="34" charset="-120"/>
               </a:rPr>
-              <a:t>1</a:t>
-            </a:r>
-            <a:endParaRPr lang="en-US" sz="1500" dirty="0"/>
-          </a:p>
-        </p:txBody>
-      </p:sp>
-      <p:sp>
-        <p:nvSpPr>
-          <p:cNvPr id="7" name="Text 5"/>
-          <p:cNvSpPr/>
-          <p:nvPr/>
-        </p:nvSpPr>
-        <p:spPr>
-          <a:xfrm>
-            <a:off x="1417320" y="2039112"/>
-            <a:ext cx="4297680" cy="411480"/>
-          </a:xfrm>
-          <a:prstGeom prst="rect">
-            <a:avLst/>
-          </a:prstGeom>
-          <a:noFill/>
-          <a:ln/>
-        </p:spPr>
-        <p:txBody>
-          <a:bodyPr wrap="square" lIns="0" tIns="0" rIns="0" bIns="0" rtlCol="0" anchor="ctr"/>
-          <a:lstStyle/>
-          <a:p>
-            <a:pPr indent="0" marL="0">
-              <a:buNone/>
-            </a:pPr>
-            <a:r>
-              <a:rPr lang="en-US" sz="1800" b="1" dirty="0">
-                <a:solidFill>
-                  <a:srgbClr val="1A1F3D"/>
-                </a:solidFill>
-                <a:latin typeface="Cambria" pitchFamily="34" charset="0"/>
-                <a:ea typeface="Cambria" pitchFamily="34" charset="-122"/>
-                <a:cs typeface="Cambria" pitchFamily="34" charset="-120"/>
-              </a:rPr>
-              <a:t>곱셈기 = LUT 구현</a:t>
-            </a:r>
-            <a:endParaRPr lang="en-US" sz="1800" dirty="0"/>
-          </a:p>
-        </p:txBody>
-      </p:sp>
-      <p:sp>
-        <p:nvSpPr>
-          <p:cNvPr id="8" name="Text 6"/>
-          <p:cNvSpPr/>
-          <p:nvPr/>
-        </p:nvSpPr>
-        <p:spPr>
-          <a:xfrm>
-            <a:off x="1005840" y="2606040"/>
-            <a:ext cx="4709160" cy="960120"/>
-          </a:xfrm>
-          <a:prstGeom prst="rect">
-            <a:avLst/>
-          </a:prstGeom>
-          <a:noFill/>
-          <a:ln/>
-        </p:spPr>
-        <p:txBody>
-          <a:bodyPr wrap="square" lIns="0" tIns="0" rIns="0" bIns="0" rtlCol="0" anchor="ctr"/>
-          <a:lstStyle/>
-          <a:p>
-            <a:pPr indent="0" marL="0">
-              <a:lnSpc>
-                <a:spcPct val="105000"/>
-              </a:lnSpc>
-              <a:buNone/>
+              <a:t>읽는 법</a:t>
+            </a:r>
+            <a:endParaRPr lang="en-US" sz="1700" dirty="0"/>
+          </a:p>
+        </p:txBody>
+      </p:sp>
+      <p:sp>
+        <p:nvSpPr>
+          <p:cNvPr id="14" name="Text 11"/>
+          <p:cNvSpPr/>
+          <p:nvPr/>
+        </p:nvSpPr>
+        <p:spPr>
+          <a:xfrm>
+            <a:off x="6858000" y="4114800"/>
+            <a:ext cx="4572000" cy="2011680"/>
+          </a:xfrm>
+          <a:prstGeom prst="rect">
+            <a:avLst/>
+          </a:prstGeom>
+          <a:noFill/>
+          <a:ln/>
+        </p:spPr>
+        <p:txBody>
+          <a:bodyPr wrap="square" lIns="0" tIns="0" rIns="0" bIns="0" rtlCol="0" anchor="ctr"/>
+          <a:lstStyle/>
+          <a:p>
+            <a:pPr marL="342900" indent="-342900">
+              <a:spcAft>
+                <a:spcPts val="900"/>
+              </a:spcAft>
+              <a:buSzPct val="100000"/>
+              <a:buChar char="•"/>
             </a:pPr>
             <a:r>
               <a:rPr lang="en-US" sz="1400" dirty="0">
@@ -7921,170 +9396,17 @@
                 <a:ea typeface="Calibri" pitchFamily="34" charset="-122"/>
                 <a:cs typeface="Calibri" pitchFamily="34" charset="-120"/>
               </a:rPr>
-              <a:t>곱셈은 정상 동작(mul 실측 확인). 단 DSP 아닌 LUT로 구현되어 면적·속도 효율은 개선 여지.</a:t>
+              <a:t>BRAM 10개 ≈ ITCM 8KB + DTCM 32KB (사양 일치)</a:t>
             </a:r>
             <a:endParaRPr lang="en-US" sz="1400" dirty="0"/>
           </a:p>
-        </p:txBody>
-      </p:sp>
-      <p:sp>
-        <p:nvSpPr>
-          <p:cNvPr id="9" name="Shape 7"/>
-          <p:cNvSpPr/>
-          <p:nvPr/>
-        </p:nvSpPr>
-        <p:spPr>
-          <a:xfrm>
-            <a:off x="6263640" y="1783080"/>
-            <a:ext cx="5349240" cy="1874520"/>
-          </a:xfrm>
-          <a:prstGeom prst="roundRect">
-            <a:avLst>
-              <a:gd name="adj" fmla="val 4878"/>
-            </a:avLst>
-          </a:prstGeom>
-          <a:solidFill>
-            <a:srgbClr val="FFFFFF"/>
-          </a:solidFill>
-          <a:ln w="12700">
-            <a:solidFill>
-              <a:srgbClr val="E2E6F0"/>
-            </a:solidFill>
-            <a:prstDash val="solid"/>
-          </a:ln>
-          <a:effectLst>
-            <a:outerShdw sx="100000" sy="100000" kx="0" ky="0" algn="bl" rotWithShape="0" blurRad="101600" dist="25400" dir="5400000">
-              <a:srgbClr val="9099B0">
-                <a:alpha val="30000"/>
-              </a:srgbClr>
-            </a:outerShdw>
-          </a:effectLst>
-        </p:spPr>
-      </p:sp>
-      <p:sp>
-        <p:nvSpPr>
-          <p:cNvPr id="10" name="Shape 8"/>
-          <p:cNvSpPr/>
-          <p:nvPr/>
-        </p:nvSpPr>
-        <p:spPr>
-          <a:xfrm>
-            <a:off x="6583680" y="2084832"/>
-            <a:ext cx="310896" cy="310896"/>
-          </a:xfrm>
-          <a:prstGeom prst="ellipse">
-            <a:avLst/>
-          </a:prstGeom>
-          <a:solidFill>
-            <a:srgbClr val="F96167"/>
-          </a:solidFill>
-          <a:ln/>
-        </p:spPr>
-      </p:sp>
-      <p:sp>
-        <p:nvSpPr>
-          <p:cNvPr id="11" name="Text 9"/>
-          <p:cNvSpPr/>
-          <p:nvPr/>
-        </p:nvSpPr>
-        <p:spPr>
-          <a:xfrm>
-            <a:off x="6583680" y="2066544"/>
-            <a:ext cx="310896" cy="310896"/>
-          </a:xfrm>
-          <a:prstGeom prst="rect">
-            <a:avLst/>
-          </a:prstGeom>
-          <a:noFill/>
-          <a:ln/>
-        </p:spPr>
-        <p:txBody>
-          <a:bodyPr wrap="square" lIns="0" tIns="0" rIns="0" bIns="0" rtlCol="0" anchor="ctr"/>
-          <a:lstStyle/>
-          <a:p>
-            <a:pPr algn="ctr" indent="0" marL="0">
-              <a:buNone/>
-            </a:pPr>
-            <a:r>
-              <a:rPr lang="en-US" sz="1500" b="1" dirty="0">
-                <a:solidFill>
-                  <a:srgbClr val="FFFFFF"/>
-                </a:solidFill>
-                <a:latin typeface="Cambria" pitchFamily="34" charset="0"/>
-                <a:ea typeface="Cambria" pitchFamily="34" charset="-122"/>
-                <a:cs typeface="Cambria" pitchFamily="34" charset="-120"/>
-              </a:rPr>
-              <a:t>2</a:t>
-            </a:r>
-            <a:endParaRPr lang="en-US" sz="1500" dirty="0"/>
-          </a:p>
-        </p:txBody>
-      </p:sp>
-      <p:sp>
-        <p:nvSpPr>
-          <p:cNvPr id="12" name="Text 10"/>
-          <p:cNvSpPr/>
-          <p:nvPr/>
-        </p:nvSpPr>
-        <p:spPr>
-          <a:xfrm>
-            <a:off x="7040880" y="2039112"/>
-            <a:ext cx="4297680" cy="411480"/>
-          </a:xfrm>
-          <a:prstGeom prst="rect">
-            <a:avLst/>
-          </a:prstGeom>
-          <a:noFill/>
-          <a:ln/>
-        </p:spPr>
-        <p:txBody>
-          <a:bodyPr wrap="square" lIns="0" tIns="0" rIns="0" bIns="0" rtlCol="0" anchor="ctr"/>
-          <a:lstStyle/>
-          <a:p>
-            <a:pPr indent="0" marL="0">
-              <a:buNone/>
-            </a:pPr>
-            <a:r>
-              <a:rPr lang="en-US" sz="1800" b="1" dirty="0">
-                <a:solidFill>
-                  <a:srgbClr val="1A1F3D"/>
-                </a:solidFill>
-                <a:latin typeface="Cambria" pitchFamily="34" charset="0"/>
-                <a:ea typeface="Cambria" pitchFamily="34" charset="-122"/>
-                <a:cs typeface="Cambria" pitchFamily="34" charset="-120"/>
-              </a:rPr>
-              <a:t>칩 규모 (최대 이슈)</a:t>
-            </a:r>
-            <a:endParaRPr lang="en-US" sz="1800" dirty="0"/>
-          </a:p>
-        </p:txBody>
-      </p:sp>
-      <p:sp>
-        <p:nvSpPr>
-          <p:cNvPr id="13" name="Text 11"/>
-          <p:cNvSpPr/>
-          <p:nvPr/>
-        </p:nvSpPr>
-        <p:spPr>
-          <a:xfrm>
-            <a:off x="6629400" y="2606040"/>
-            <a:ext cx="4709160" cy="960120"/>
-          </a:xfrm>
-          <a:prstGeom prst="rect">
-            <a:avLst/>
-          </a:prstGeom>
-          <a:noFill/>
-          <a:ln/>
-        </p:spPr>
-        <p:txBody>
-          <a:bodyPr wrap="square" lIns="0" tIns="0" rIns="0" bIns="0" rtlCol="0" anchor="ctr"/>
-          <a:lstStyle/>
-          <a:p>
-            <a:pPr indent="0" marL="0">
-              <a:lnSpc>
-                <a:spcPct val="105000"/>
-              </a:lnSpc>
-              <a:buNone/>
+          <a:p>
+            <a:pPr marL="342900" indent="-342900">
+              <a:spcAft>
+                <a:spcPts val="900"/>
+              </a:spcAft>
+              <a:buSzPct val="100000"/>
+              <a:buChar char="•"/>
             </a:pPr>
             <a:r>
               <a:rPr lang="en-US" sz="1400" dirty="0">
@@ -8095,170 +9417,17 @@
                 <a:ea typeface="Calibri" pitchFamily="34" charset="-122"/>
                 <a:cs typeface="Calibri" pitchFamily="34" charset="-120"/>
               </a:rPr>
-              <a:t>Coral 기본 타깃 xcvu13p 대비 ZU9EG는 약 6배 작음 → NPU 코어만 분리 합성.</a:t>
+              <a:t>DSP 6개뿐 → 곱셈이 DSP 아닌 LUT로 구현됨</a:t>
             </a:r>
             <a:endParaRPr lang="en-US" sz="1400" dirty="0"/>
           </a:p>
-        </p:txBody>
-      </p:sp>
-      <p:sp>
-        <p:nvSpPr>
-          <p:cNvPr id="14" name="Shape 12"/>
-          <p:cNvSpPr/>
-          <p:nvPr/>
-        </p:nvSpPr>
-        <p:spPr>
-          <a:xfrm>
-            <a:off x="640080" y="3931920"/>
-            <a:ext cx="5349240" cy="1874520"/>
-          </a:xfrm>
-          <a:prstGeom prst="roundRect">
-            <a:avLst>
-              <a:gd name="adj" fmla="val 4878"/>
-            </a:avLst>
-          </a:prstGeom>
-          <a:solidFill>
-            <a:srgbClr val="FFFFFF"/>
-          </a:solidFill>
-          <a:ln w="12700">
-            <a:solidFill>
-              <a:srgbClr val="E2E6F0"/>
-            </a:solidFill>
-            <a:prstDash val="solid"/>
-          </a:ln>
-          <a:effectLst>
-            <a:outerShdw sx="100000" sy="100000" kx="0" ky="0" algn="bl" rotWithShape="0" blurRad="101600" dist="25400" dir="5400000">
-              <a:srgbClr val="9099B0">
-                <a:alpha val="30000"/>
-              </a:srgbClr>
-            </a:outerShdw>
-          </a:effectLst>
-        </p:spPr>
-      </p:sp>
-      <p:sp>
-        <p:nvSpPr>
-          <p:cNvPr id="15" name="Shape 13"/>
-          <p:cNvSpPr/>
-          <p:nvPr/>
-        </p:nvSpPr>
-        <p:spPr>
-          <a:xfrm>
-            <a:off x="960120" y="4233672"/>
-            <a:ext cx="310896" cy="310896"/>
-          </a:xfrm>
-          <a:prstGeom prst="ellipse">
-            <a:avLst/>
-          </a:prstGeom>
-          <a:solidFill>
-            <a:srgbClr val="F96167"/>
-          </a:solidFill>
-          <a:ln/>
-        </p:spPr>
-      </p:sp>
-      <p:sp>
-        <p:nvSpPr>
-          <p:cNvPr id="16" name="Text 14"/>
-          <p:cNvSpPr/>
-          <p:nvPr/>
-        </p:nvSpPr>
-        <p:spPr>
-          <a:xfrm>
-            <a:off x="960120" y="4215384"/>
-            <a:ext cx="310896" cy="310896"/>
-          </a:xfrm>
-          <a:prstGeom prst="rect">
-            <a:avLst/>
-          </a:prstGeom>
-          <a:noFill/>
-          <a:ln/>
-        </p:spPr>
-        <p:txBody>
-          <a:bodyPr wrap="square" lIns="0" tIns="0" rIns="0" bIns="0" rtlCol="0" anchor="ctr"/>
-          <a:lstStyle/>
-          <a:p>
-            <a:pPr algn="ctr" indent="0" marL="0">
-              <a:buNone/>
-            </a:pPr>
-            <a:r>
-              <a:rPr lang="en-US" sz="1500" b="1" dirty="0">
-                <a:solidFill>
-                  <a:srgbClr val="FFFFFF"/>
-                </a:solidFill>
-                <a:latin typeface="Cambria" pitchFamily="34" charset="0"/>
-                <a:ea typeface="Cambria" pitchFamily="34" charset="-122"/>
-                <a:cs typeface="Cambria" pitchFamily="34" charset="-120"/>
-              </a:rPr>
-              <a:t>3</a:t>
-            </a:r>
-            <a:endParaRPr lang="en-US" sz="1500" dirty="0"/>
-          </a:p>
-        </p:txBody>
-      </p:sp>
-      <p:sp>
-        <p:nvSpPr>
-          <p:cNvPr id="17" name="Text 15"/>
-          <p:cNvSpPr/>
-          <p:nvPr/>
-        </p:nvSpPr>
-        <p:spPr>
-          <a:xfrm>
-            <a:off x="1417320" y="4187952"/>
-            <a:ext cx="4297680" cy="411480"/>
-          </a:xfrm>
-          <a:prstGeom prst="rect">
-            <a:avLst/>
-          </a:prstGeom>
-          <a:noFill/>
-          <a:ln/>
-        </p:spPr>
-        <p:txBody>
-          <a:bodyPr wrap="square" lIns="0" tIns="0" rIns="0" bIns="0" rtlCol="0" anchor="ctr"/>
-          <a:lstStyle/>
-          <a:p>
-            <a:pPr indent="0" marL="0">
-              <a:buNone/>
-            </a:pPr>
-            <a:r>
-              <a:rPr lang="en-US" sz="1800" b="1" dirty="0">
-                <a:solidFill>
-                  <a:srgbClr val="1A1F3D"/>
-                </a:solidFill>
-                <a:latin typeface="Cambria" pitchFamily="34" charset="0"/>
-                <a:ea typeface="Cambria" pitchFamily="34" charset="-122"/>
-                <a:cs typeface="Cambria" pitchFamily="34" charset="-120"/>
-              </a:rPr>
-              <a:t>클럭 상한 50MHz</a:t>
-            </a:r>
-            <a:endParaRPr lang="en-US" sz="1800" dirty="0"/>
-          </a:p>
-        </p:txBody>
-      </p:sp>
-      <p:sp>
-        <p:nvSpPr>
-          <p:cNvPr id="18" name="Text 16"/>
-          <p:cNvSpPr/>
-          <p:nvPr/>
-        </p:nvSpPr>
-        <p:spPr>
-          <a:xfrm>
-            <a:off x="1005840" y="4754880"/>
-            <a:ext cx="4709160" cy="960120"/>
-          </a:xfrm>
-          <a:prstGeom prst="rect">
-            <a:avLst/>
-          </a:prstGeom>
-          <a:noFill/>
-          <a:ln/>
-        </p:spPr>
-        <p:txBody>
-          <a:bodyPr wrap="square" lIns="0" tIns="0" rIns="0" bIns="0" rtlCol="0" anchor="ctr"/>
-          <a:lstStyle/>
-          <a:p>
-            <a:pPr indent="0" marL="0">
-              <a:lnSpc>
-                <a:spcPct val="105000"/>
-              </a:lnSpc>
-              <a:buNone/>
+          <a:p>
+            <a:pPr marL="342900" indent="-342900">
+              <a:spcAft>
+                <a:spcPts val="900"/>
+              </a:spcAft>
+              <a:buSzPct val="100000"/>
+              <a:buChar char="•"/>
             </a:pPr>
             <a:r>
               <a:rPr lang="en-US" sz="1400" dirty="0">
@@ -8269,181 +9438,7 @@
                 <a:ea typeface="Calibri" pitchFamily="34" charset="-122"/>
                 <a:cs typeface="Calibri" pitchFamily="34" charset="-120"/>
               </a:rPr>
-              <a:t>100MHz는 타이밍 위반 → 50MHz로 하향해 안정 동작.</a:t>
-            </a:r>
-            <a:endParaRPr lang="en-US" sz="1400" dirty="0"/>
-          </a:p>
-        </p:txBody>
-      </p:sp>
-      <p:sp>
-        <p:nvSpPr>
-          <p:cNvPr id="19" name="Shape 17"/>
-          <p:cNvSpPr/>
-          <p:nvPr/>
-        </p:nvSpPr>
-        <p:spPr>
-          <a:xfrm>
-            <a:off x="6263640" y="3931920"/>
-            <a:ext cx="5349240" cy="1874520"/>
-          </a:xfrm>
-          <a:prstGeom prst="roundRect">
-            <a:avLst>
-              <a:gd name="adj" fmla="val 4878"/>
-            </a:avLst>
-          </a:prstGeom>
-          <a:solidFill>
-            <a:srgbClr val="FFFFFF"/>
-          </a:solidFill>
-          <a:ln w="12700">
-            <a:solidFill>
-              <a:srgbClr val="E2E6F0"/>
-            </a:solidFill>
-            <a:prstDash val="solid"/>
-          </a:ln>
-          <a:effectLst>
-            <a:outerShdw sx="100000" sy="100000" kx="0" ky="0" algn="bl" rotWithShape="0" blurRad="101600" dist="25400" dir="5400000">
-              <a:srgbClr val="9099B0">
-                <a:alpha val="30000"/>
-              </a:srgbClr>
-            </a:outerShdw>
-          </a:effectLst>
-        </p:spPr>
-      </p:sp>
-      <p:sp>
-        <p:nvSpPr>
-          <p:cNvPr id="20" name="Shape 18"/>
-          <p:cNvSpPr/>
-          <p:nvPr/>
-        </p:nvSpPr>
-        <p:spPr>
-          <a:xfrm>
-            <a:off x="6583680" y="4233672"/>
-            <a:ext cx="310896" cy="310896"/>
-          </a:xfrm>
-          <a:prstGeom prst="ellipse">
-            <a:avLst/>
-          </a:prstGeom>
-          <a:solidFill>
-            <a:srgbClr val="F96167"/>
-          </a:solidFill>
-          <a:ln/>
-        </p:spPr>
-      </p:sp>
-      <p:sp>
-        <p:nvSpPr>
-          <p:cNvPr id="21" name="Text 19"/>
-          <p:cNvSpPr/>
-          <p:nvPr/>
-        </p:nvSpPr>
-        <p:spPr>
-          <a:xfrm>
-            <a:off x="6583680" y="4215384"/>
-            <a:ext cx="310896" cy="310896"/>
-          </a:xfrm>
-          <a:prstGeom prst="rect">
-            <a:avLst/>
-          </a:prstGeom>
-          <a:noFill/>
-          <a:ln/>
-        </p:spPr>
-        <p:txBody>
-          <a:bodyPr wrap="square" lIns="0" tIns="0" rIns="0" bIns="0" rtlCol="0" anchor="ctr"/>
-          <a:lstStyle/>
-          <a:p>
-            <a:pPr algn="ctr" indent="0" marL="0">
-              <a:buNone/>
-            </a:pPr>
-            <a:r>
-              <a:rPr lang="en-US" sz="1500" b="1" dirty="0">
-                <a:solidFill>
-                  <a:srgbClr val="FFFFFF"/>
-                </a:solidFill>
-                <a:latin typeface="Cambria" pitchFamily="34" charset="0"/>
-                <a:ea typeface="Cambria" pitchFamily="34" charset="-122"/>
-                <a:cs typeface="Cambria" pitchFamily="34" charset="-120"/>
-              </a:rPr>
-              <a:t>4</a:t>
-            </a:r>
-            <a:endParaRPr lang="en-US" sz="1500" dirty="0"/>
-          </a:p>
-        </p:txBody>
-      </p:sp>
-      <p:sp>
-        <p:nvSpPr>
-          <p:cNvPr id="22" name="Text 20"/>
-          <p:cNvSpPr/>
-          <p:nvPr/>
-        </p:nvSpPr>
-        <p:spPr>
-          <a:xfrm>
-            <a:off x="7040880" y="4187952"/>
-            <a:ext cx="4297680" cy="411480"/>
-          </a:xfrm>
-          <a:prstGeom prst="rect">
-            <a:avLst/>
-          </a:prstGeom>
-          <a:noFill/>
-          <a:ln/>
-        </p:spPr>
-        <p:txBody>
-          <a:bodyPr wrap="square" lIns="0" tIns="0" rIns="0" bIns="0" rtlCol="0" anchor="ctr"/>
-          <a:lstStyle/>
-          <a:p>
-            <a:pPr indent="0" marL="0">
-              <a:buNone/>
-            </a:pPr>
-            <a:r>
-              <a:rPr lang="en-US" sz="1800" b="1" dirty="0">
-                <a:solidFill>
-                  <a:srgbClr val="1A1F3D"/>
-                </a:solidFill>
-                <a:latin typeface="Cambria" pitchFamily="34" charset="0"/>
-                <a:ea typeface="Cambria" pitchFamily="34" charset="-122"/>
-                <a:cs typeface="Cambria" pitchFamily="34" charset="-120"/>
-              </a:rPr>
-              <a:t>ZCU102 공식 미지원</a:t>
-            </a:r>
-            <a:endParaRPr lang="en-US" sz="1800" dirty="0"/>
-          </a:p>
-        </p:txBody>
-      </p:sp>
-      <p:sp>
-        <p:nvSpPr>
-          <p:cNvPr id="23" name="Text 21"/>
-          <p:cNvSpPr/>
-          <p:nvPr/>
-        </p:nvSpPr>
-        <p:spPr>
-          <a:xfrm>
-            <a:off x="6629400" y="4754880"/>
-            <a:ext cx="4709160" cy="960120"/>
-          </a:xfrm>
-          <a:prstGeom prst="rect">
-            <a:avLst/>
-          </a:prstGeom>
-          <a:noFill/>
-          <a:ln/>
-        </p:spPr>
-        <p:txBody>
-          <a:bodyPr wrap="square" lIns="0" tIns="0" rIns="0" bIns="0" rtlCol="0" anchor="ctr"/>
-          <a:lstStyle/>
-          <a:p>
-            <a:pPr indent="0" marL="0">
-              <a:lnSpc>
-                <a:spcPct val="105000"/>
-              </a:lnSpc>
-              <a:buNone/>
-            </a:pPr>
-            <a:r>
-              <a:rPr lang="en-US" sz="1400" dirty="0">
-                <a:solidFill>
-                  <a:srgbClr val="5A6072"/>
-                </a:solidFill>
-                <a:latin typeface="Calibri" pitchFamily="34" charset="0"/>
-                <a:ea typeface="Calibri" pitchFamily="34" charset="-122"/>
-                <a:cs typeface="Calibri" pitchFamily="34" charset="-120"/>
-              </a:rPr>
-              <a:t>사내(Nexus) 보드 전제 → AXI wrapper·XDC 직접 작성으로 대응.</a:t>
+              <a:t>NPU 코어가 사용량 대부분 (18% 수준)</a:t>
             </a:r>
             <a:endParaRPr lang="en-US" sz="1400" dirty="0"/>
           </a:p>

</xml_diff>